<commit_message>
design: PPTX 2차 수정 (4가지 주문 반영)
① 페이지 제목을 제외한 텍스트 30% 키움
- 카드 제목: 12.5→16, 본문: 11→14, row_card 라벨: 11.5→15
- 표지 한 줄 소개: 17→22, 발표자/링크: 11→14, 라벨: 8.5→11
- kicker: 10→13, 하단 한계: 9.5→12.5, 표 본문: 11→14
- 페이지 제목(영문 카테고리, 한국어 부제, 표지 TubeBrief)은 그대로

② 페이지 제목 구분선을 제목 바로 밑으로 (1.75→1.62)

③ 모든 박스를 둥근 모서리로 (corner_pct=0.06 통일)
- add_rect 기본을 rounded=True 로 변경
- add_card 의 본 카드 + 그림자 모두 ROUNDED_RECTANGLE
- 강의 칩, T 마크, kicker 강조 박스, 아이콘 정사각형 모두 둥글게
- divider 같이 얇은 라인만 rounded=False

④ 마지막 페이지(NEXT) 레이아웃 재배치
- 상단: 좌측 어려움+해결(3.4h) / 우측 결과 비교(3.4h)
- 하단: LIMITATION 박스(전체 폭 12.0, 1.65h)
- LIMITATION 도 박스 안에 위치, kicker + 3개 항목
</commit_message>
<xml_diff>
--- a/이용주-기말발표자료.pptx
+++ b/이용주-기말발표자료.pptx
@@ -3237,7 +3237,7 @@
         <p:spPr>
           <a:xfrm>
             <a:off x="640080" y="640080"/>
-            <a:ext cx="3291840" cy="365760"/>
+            <a:ext cx="3291840" cy="411480"/>
           </a:xfrm>
           <a:prstGeom prst="roundRect">
             <a:avLst>
@@ -3285,7 +3285,7 @@
         <p:spPr>
           <a:xfrm>
             <a:off x="777240" y="640080"/>
-            <a:ext cx="3108960" cy="365760"/>
+            <a:ext cx="3108960" cy="411480"/>
           </a:xfrm>
           <a:prstGeom prst="rect">
             <a:avLst/>
@@ -3300,7 +3300,7 @@
           <a:p>
             <a:pPr algn="l"/>
             <a:r>
-              <a:rPr sz="950">
+              <a:rPr sz="1200">
                 <a:solidFill>
                   <a:srgbClr val="2D4A3E"/>
                 </a:solidFill>
@@ -3314,7 +3314,7 @@
       </p:sp>
       <p:sp>
         <p:nvSpPr>
-          <p:cNvPr id="7" name="Rectangle 6"/>
+          <p:cNvPr id="7" name="Rounded Rectangle 6"/>
           <p:cNvSpPr/>
           <p:nvPr/>
         </p:nvSpPr>
@@ -3323,8 +3323,10 @@
             <a:off x="640080" y="2194560"/>
             <a:ext cx="868680" cy="868680"/>
           </a:xfrm>
-          <a:prstGeom prst="rect">
-            <a:avLst/>
+          <a:prstGeom prst="roundRect">
+            <a:avLst>
+              <a:gd name="adj" fmla="val 18000"/>
+            </a:avLst>
           </a:prstGeom>
           <a:solidFill>
             <a:srgbClr val="2D4A3E"/>
@@ -3401,7 +3403,7 @@
         <p:spPr>
           <a:xfrm>
             <a:off x="1645920" y="2331720"/>
-            <a:ext cx="5486400" cy="365760"/>
+            <a:ext cx="5486400" cy="457200"/>
           </a:xfrm>
           <a:prstGeom prst="rect">
             <a:avLst/>
@@ -3416,7 +3418,7 @@
           <a:p>
             <a:pPr algn="l"/>
             <a:r>
-              <a:rPr sz="1100">
+              <a:rPr sz="1400">
                 <a:solidFill>
                   <a:srgbClr val="9B9182"/>
                 </a:solidFill>
@@ -3509,7 +3511,7 @@
         <p:spPr>
           <a:xfrm>
             <a:off x="640080" y="4800600"/>
-            <a:ext cx="8229600" cy="914400"/>
+            <a:ext cx="8229600" cy="1097280"/>
           </a:xfrm>
           <a:prstGeom prst="rect">
             <a:avLst/>
@@ -3528,7 +3530,7 @@
               </a:lnSpc>
             </a:pPr>
             <a:r>
-              <a:rPr sz="1700">
+              <a:rPr sz="2200">
                 <a:solidFill>
                   <a:srgbClr val="6B6356"/>
                 </a:solidFill>
@@ -3608,7 +3610,7 @@
           <a:p>
             <a:pPr algn="l"/>
             <a:r>
-              <a:rPr sz="850">
+              <a:rPr sz="1100">
                 <a:solidFill>
                   <a:srgbClr val="9B9182"/>
                 </a:solidFill>
@@ -3644,7 +3646,7 @@
           <a:p>
             <a:pPr algn="l"/>
             <a:r>
-              <a:rPr sz="1100">
+              <a:rPr sz="1400">
                 <a:solidFill>
                   <a:srgbClr val="2C2418"/>
                 </a:solidFill>
@@ -3680,7 +3682,7 @@
           <a:p>
             <a:pPr algn="l"/>
             <a:r>
-              <a:rPr sz="850">
+              <a:rPr sz="1100">
                 <a:solidFill>
                   <a:srgbClr val="9B9182"/>
                 </a:solidFill>
@@ -3716,7 +3718,7 @@
           <a:p>
             <a:pPr algn="l"/>
             <a:r>
-              <a:rPr sz="1100" u="sng">
+              <a:rPr sz="1400" u="sng">
                 <a:solidFill>
                   <a:srgbClr val="B5793E"/>
                 </a:solidFill>
@@ -3753,7 +3755,7 @@
           <a:p>
             <a:pPr algn="l"/>
             <a:r>
-              <a:rPr sz="850">
+              <a:rPr sz="1100">
                 <a:solidFill>
                   <a:srgbClr val="9B9182"/>
                 </a:solidFill>
@@ -3789,7 +3791,7 @@
           <a:p>
             <a:pPr algn="l"/>
             <a:r>
-              <a:rPr sz="1100" u="sng">
+              <a:rPr sz="1400" u="sng">
                 <a:solidFill>
                   <a:srgbClr val="B5793E"/>
                 </a:solidFill>
@@ -3944,7 +3946,7 @@
         </p:nvSpPr>
         <p:spPr>
           <a:xfrm>
-            <a:off x="640080" y="1600200"/>
+            <a:off x="640080" y="1481328"/>
             <a:ext cx="10881360" cy="13716"/>
           </a:xfrm>
           <a:prstGeom prst="rect">
@@ -4004,7 +4006,7 @@
           <a:p>
             <a:pPr algn="r"/>
             <a:r>
-              <a:rPr sz="900">
+              <a:rPr sz="1150">
                 <a:solidFill>
                   <a:srgbClr val="9B9182"/>
                 </a:solidFill>
@@ -4018,17 +4020,19 @@
       </p:sp>
       <p:sp>
         <p:nvSpPr>
-          <p:cNvPr id="7" name="Rectangle 6"/>
+          <p:cNvPr id="7" name="Rounded Rectangle 6"/>
           <p:cNvSpPr/>
           <p:nvPr/>
         </p:nvSpPr>
         <p:spPr>
           <a:xfrm>
-            <a:off x="676656" y="1956816"/>
-            <a:ext cx="5440680" cy="4480560"/>
-          </a:xfrm>
-          <a:prstGeom prst="rect">
-            <a:avLst/>
+            <a:off x="676656" y="1865376"/>
+            <a:ext cx="5440680" cy="4572000"/>
+          </a:xfrm>
+          <a:prstGeom prst="roundRect">
+            <a:avLst>
+              <a:gd name="adj" fmla="val 6000"/>
+            </a:avLst>
           </a:prstGeom>
           <a:solidFill>
             <a:srgbClr val="D5C9B4"/>
@@ -4062,17 +4066,19 @@
       </p:sp>
       <p:sp>
         <p:nvSpPr>
-          <p:cNvPr id="8" name="Rectangle 7"/>
+          <p:cNvPr id="8" name="Rounded Rectangle 7"/>
           <p:cNvSpPr/>
           <p:nvPr/>
         </p:nvSpPr>
         <p:spPr>
           <a:xfrm>
-            <a:off x="640080" y="1920240"/>
-            <a:ext cx="5440680" cy="4480560"/>
-          </a:xfrm>
-          <a:prstGeom prst="rect">
-            <a:avLst/>
+            <a:off x="640080" y="1828800"/>
+            <a:ext cx="5440680" cy="4572000"/>
+          </a:xfrm>
+          <a:prstGeom prst="roundRect">
+            <a:avLst>
+              <a:gd name="adj" fmla="val 6000"/>
+            </a:avLst>
           </a:prstGeom>
           <a:solidFill>
             <a:srgbClr val="FFFFFF"/>
@@ -4114,8 +4120,8 @@
         </p:nvSpPr>
         <p:spPr>
           <a:xfrm>
-            <a:off x="868680" y="2148840"/>
-            <a:ext cx="2743200" cy="274320"/>
+            <a:off x="868680" y="2057400"/>
+            <a:ext cx="3657600" cy="274320"/>
           </a:xfrm>
           <a:prstGeom prst="rect">
             <a:avLst/>
@@ -4130,7 +4136,7 @@
           <a:p>
             <a:pPr algn="l"/>
             <a:r>
-              <a:rPr sz="1000">
+              <a:rPr sz="1300">
                 <a:solidFill>
                   <a:srgbClr val="8B2635"/>
                 </a:solidFill>
@@ -4150,7 +4156,7 @@
         </p:nvSpPr>
         <p:spPr>
           <a:xfrm>
-            <a:off x="868680" y="2468880"/>
+            <a:off x="868680" y="2423160"/>
             <a:ext cx="5029200" cy="411480"/>
           </a:xfrm>
           <a:prstGeom prst="rect">
@@ -4166,7 +4172,7 @@
           <a:p>
             <a:pPr algn="l"/>
             <a:r>
-              <a:rPr sz="1500">
+              <a:rPr sz="1950">
                 <a:solidFill>
                   <a:srgbClr val="2C2418"/>
                 </a:solidFill>
@@ -4187,7 +4193,7 @@
         <p:spPr>
           <a:xfrm>
             <a:off x="868680" y="3108960"/>
-            <a:ext cx="5029200" cy="3108960"/>
+            <a:ext cx="5029200" cy="3200400"/>
           </a:xfrm>
           <a:prstGeom prst="rect">
             <a:avLst/>
@@ -4206,7 +4212,7 @@
               </a:lnSpc>
             </a:pPr>
             <a:r>
-              <a:rPr sz="1200">
+              <a:rPr sz="1550">
                 <a:solidFill>
                   <a:srgbClr val="6B6356"/>
                 </a:solidFill>
@@ -4223,7 +4229,7 @@
               </a:lnSpc>
             </a:pPr>
             <a:r>
-              <a:rPr sz="1200">
+              <a:rPr sz="1550">
                 <a:solidFill>
                   <a:srgbClr val="6B6356"/>
                 </a:solidFill>
@@ -4240,7 +4246,7 @@
               </a:lnSpc>
             </a:pPr>
             <a:r>
-              <a:rPr sz="1200">
+              <a:rPr sz="1550">
                 <a:solidFill>
                   <a:srgbClr val="6B6356"/>
                 </a:solidFill>
@@ -4257,7 +4263,7 @@
               </a:lnSpc>
             </a:pPr>
             <a:r>
-              <a:rPr sz="1200">
+              <a:rPr sz="1550">
                 <a:solidFill>
                   <a:srgbClr val="6B6356"/>
                 </a:solidFill>
@@ -4274,7 +4280,7 @@
               </a:lnSpc>
             </a:pPr>
             <a:r>
-              <a:rPr sz="1200">
+              <a:rPr sz="1550">
                 <a:solidFill>
                   <a:srgbClr val="6B6356"/>
                 </a:solidFill>
@@ -4288,17 +4294,19 @@
       </p:sp>
       <p:sp>
         <p:nvSpPr>
-          <p:cNvPr id="12" name="Rectangle 11"/>
+          <p:cNvPr id="12" name="Rounded Rectangle 11"/>
           <p:cNvSpPr/>
           <p:nvPr/>
         </p:nvSpPr>
         <p:spPr>
           <a:xfrm>
-            <a:off x="6300216" y="1956816"/>
-            <a:ext cx="5440680" cy="4480560"/>
-          </a:xfrm>
-          <a:prstGeom prst="rect">
-            <a:avLst/>
+            <a:off x="6300216" y="1865376"/>
+            <a:ext cx="5440680" cy="4572000"/>
+          </a:xfrm>
+          <a:prstGeom prst="roundRect">
+            <a:avLst>
+              <a:gd name="adj" fmla="val 6000"/>
+            </a:avLst>
           </a:prstGeom>
           <a:solidFill>
             <a:srgbClr val="D5C9B4"/>
@@ -4332,17 +4340,19 @@
       </p:sp>
       <p:sp>
         <p:nvSpPr>
-          <p:cNvPr id="13" name="Rectangle 12"/>
+          <p:cNvPr id="13" name="Rounded Rectangle 12"/>
           <p:cNvSpPr/>
           <p:nvPr/>
         </p:nvSpPr>
         <p:spPr>
           <a:xfrm>
-            <a:off x="6263640" y="1920240"/>
-            <a:ext cx="5440680" cy="4480560"/>
-          </a:xfrm>
-          <a:prstGeom prst="rect">
-            <a:avLst/>
+            <a:off x="6263640" y="1828800"/>
+            <a:ext cx="5440680" cy="4572000"/>
+          </a:xfrm>
+          <a:prstGeom prst="roundRect">
+            <a:avLst>
+              <a:gd name="adj" fmla="val 6000"/>
+            </a:avLst>
           </a:prstGeom>
           <a:solidFill>
             <a:srgbClr val="FFFFFF"/>
@@ -4384,8 +4394,8 @@
         </p:nvSpPr>
         <p:spPr>
           <a:xfrm>
-            <a:off x="6492240" y="2148840"/>
-            <a:ext cx="2743200" cy="274320"/>
+            <a:off x="6492240" y="2057400"/>
+            <a:ext cx="3657600" cy="274320"/>
           </a:xfrm>
           <a:prstGeom prst="rect">
             <a:avLst/>
@@ -4400,7 +4410,7 @@
           <a:p>
             <a:pPr algn="l"/>
             <a:r>
-              <a:rPr sz="1000">
+              <a:rPr sz="1300">
                 <a:solidFill>
                   <a:srgbClr val="2D4A3E"/>
                 </a:solidFill>
@@ -4420,7 +4430,7 @@
         </p:nvSpPr>
         <p:spPr>
           <a:xfrm>
-            <a:off x="6492240" y="2468880"/>
+            <a:off x="6492240" y="2423160"/>
             <a:ext cx="5029200" cy="411480"/>
           </a:xfrm>
           <a:prstGeom prst="rect">
@@ -4436,7 +4446,7 @@
           <a:p>
             <a:pPr algn="l"/>
             <a:r>
-              <a:rPr sz="1500">
+              <a:rPr sz="1950">
                 <a:solidFill>
                   <a:srgbClr val="2C2418"/>
                 </a:solidFill>
@@ -4457,7 +4467,7 @@
         <p:spPr>
           <a:xfrm>
             <a:off x="6492240" y="3108960"/>
-            <a:ext cx="5029200" cy="1828800"/>
+            <a:ext cx="5029200" cy="2011680"/>
           </a:xfrm>
           <a:prstGeom prst="rect">
             <a:avLst/>
@@ -4476,7 +4486,7 @@
               </a:lnSpc>
             </a:pPr>
             <a:r>
-              <a:rPr sz="1200">
+              <a:rPr sz="1550">
                 <a:solidFill>
                   <a:srgbClr val="6B6356"/>
                 </a:solidFill>
@@ -4493,7 +4503,7 @@
               </a:lnSpc>
             </a:pPr>
             <a:r>
-              <a:rPr sz="1200">
+              <a:rPr sz="1550">
                 <a:solidFill>
                   <a:srgbClr val="6B6356"/>
                 </a:solidFill>
@@ -4510,7 +4520,7 @@
               </a:lnSpc>
             </a:pPr>
             <a:r>
-              <a:rPr sz="1200">
+              <a:rPr sz="1550">
                 <a:solidFill>
                   <a:srgbClr val="6B6356"/>
                 </a:solidFill>
@@ -4524,17 +4534,19 @@
       </p:sp>
       <p:sp>
         <p:nvSpPr>
-          <p:cNvPr id="17" name="Rectangle 16"/>
+          <p:cNvPr id="17" name="Rounded Rectangle 16"/>
           <p:cNvSpPr/>
           <p:nvPr/>
         </p:nvSpPr>
         <p:spPr>
           <a:xfrm>
-            <a:off x="6492240" y="5074920"/>
+            <a:off x="6492240" y="5166360"/>
             <a:ext cx="5074920" cy="1188720"/>
           </a:xfrm>
-          <a:prstGeom prst="rect">
-            <a:avLst/>
+          <a:prstGeom prst="roundRect">
+            <a:avLst>
+              <a:gd name="adj" fmla="val 6000"/>
+            </a:avLst>
           </a:prstGeom>
           <a:solidFill>
             <a:srgbClr val="F9F5EE"/>
@@ -4576,7 +4588,7 @@
         </p:nvSpPr>
         <p:spPr>
           <a:xfrm>
-            <a:off x="6675120" y="5212080"/>
+            <a:off x="6675120" y="5303520"/>
             <a:ext cx="4754880" cy="914400"/>
           </a:xfrm>
           <a:prstGeom prst="rect">
@@ -4596,7 +4608,7 @@
               </a:lnSpc>
             </a:pPr>
             <a:r>
-              <a:rPr sz="1150">
+              <a:rPr sz="1500">
                 <a:solidFill>
                   <a:srgbClr val="2C2418"/>
                 </a:solidFill>
@@ -4613,7 +4625,7 @@
               </a:lnSpc>
             </a:pPr>
             <a:r>
-              <a:rPr sz="1150">
+              <a:rPr sz="1500">
                 <a:solidFill>
                   <a:srgbClr val="2C2418"/>
                 </a:solidFill>
@@ -4767,7 +4779,7 @@
         </p:nvSpPr>
         <p:spPr>
           <a:xfrm>
-            <a:off x="640080" y="1600200"/>
+            <a:off x="640080" y="1481328"/>
             <a:ext cx="10881360" cy="13716"/>
           </a:xfrm>
           <a:prstGeom prst="rect">
@@ -4827,7 +4839,7 @@
           <a:p>
             <a:pPr algn="r"/>
             <a:r>
-              <a:rPr sz="900">
+              <a:rPr sz="1150">
                 <a:solidFill>
                   <a:srgbClr val="9B9182"/>
                 </a:solidFill>
@@ -4841,17 +4853,19 @@
       </p:sp>
       <p:sp>
         <p:nvSpPr>
-          <p:cNvPr id="7" name="Rectangle 6"/>
+          <p:cNvPr id="7" name="Rounded Rectangle 6"/>
           <p:cNvSpPr/>
           <p:nvPr/>
         </p:nvSpPr>
         <p:spPr>
           <a:xfrm>
-            <a:off x="676656" y="1911095"/>
-            <a:ext cx="3566160" cy="1965960"/>
-          </a:xfrm>
-          <a:prstGeom prst="rect">
-            <a:avLst/>
+            <a:off x="676656" y="1819656"/>
+            <a:ext cx="3566160" cy="2057400"/>
+          </a:xfrm>
+          <a:prstGeom prst="roundRect">
+            <a:avLst>
+              <a:gd name="adj" fmla="val 6000"/>
+            </a:avLst>
           </a:prstGeom>
           <a:solidFill>
             <a:srgbClr val="D5C9B4"/>
@@ -4885,17 +4899,19 @@
       </p:sp>
       <p:sp>
         <p:nvSpPr>
-          <p:cNvPr id="8" name="Rectangle 7"/>
+          <p:cNvPr id="8" name="Rounded Rectangle 7"/>
           <p:cNvSpPr/>
           <p:nvPr/>
         </p:nvSpPr>
         <p:spPr>
           <a:xfrm>
-            <a:off x="640080" y="1874519"/>
-            <a:ext cx="3566160" cy="1965960"/>
-          </a:xfrm>
-          <a:prstGeom prst="rect">
-            <a:avLst/>
+            <a:off x="640080" y="1783080"/>
+            <a:ext cx="3566160" cy="2057400"/>
+          </a:xfrm>
+          <a:prstGeom prst="roundRect">
+            <a:avLst>
+              <a:gd name="adj" fmla="val 6000"/>
+            </a:avLst>
           </a:prstGeom>
           <a:solidFill>
             <a:srgbClr val="FFFFFF"/>
@@ -4931,17 +4947,19 @@
       </p:sp>
       <p:sp>
         <p:nvSpPr>
-          <p:cNvPr id="9" name="Rectangle 8"/>
+          <p:cNvPr id="9" name="Rounded Rectangle 8"/>
           <p:cNvSpPr/>
           <p:nvPr/>
         </p:nvSpPr>
         <p:spPr>
           <a:xfrm>
-            <a:off x="914400" y="2148839"/>
+            <a:off x="914400" y="2057400"/>
             <a:ext cx="365760" cy="365760"/>
           </a:xfrm>
-          <a:prstGeom prst="rect">
-            <a:avLst/>
+          <a:prstGeom prst="roundRect">
+            <a:avLst>
+              <a:gd name="adj" fmla="val 20000"/>
+            </a:avLst>
           </a:prstGeom>
           <a:solidFill>
             <a:srgbClr val="2D4A3E"/>
@@ -4981,7 +4999,7 @@
         </p:nvSpPr>
         <p:spPr>
           <a:xfrm>
-            <a:off x="1417319" y="2148839"/>
+            <a:off x="1417319" y="2057400"/>
             <a:ext cx="2560320" cy="411480"/>
           </a:xfrm>
           <a:prstGeom prst="rect">
@@ -4997,7 +5015,7 @@
           <a:p>
             <a:pPr algn="l"/>
             <a:r>
-              <a:rPr sz="1250">
+              <a:rPr sz="1600">
                 <a:solidFill>
                   <a:srgbClr val="2C2418"/>
                 </a:solidFill>
@@ -5017,8 +5035,8 @@
         </p:nvSpPr>
         <p:spPr>
           <a:xfrm>
-            <a:off x="914400" y="2743200"/>
-            <a:ext cx="3017520" cy="960119"/>
+            <a:off x="914400" y="2651760"/>
+            <a:ext cx="3017520" cy="1051560"/>
           </a:xfrm>
           <a:prstGeom prst="rect">
             <a:avLst/>
@@ -5037,7 +5055,7 @@
               </a:lnSpc>
             </a:pPr>
             <a:r>
-              <a:rPr sz="1100">
+              <a:rPr sz="1400">
                 <a:solidFill>
                   <a:srgbClr val="6B6356"/>
                 </a:solidFill>
@@ -5051,17 +5069,19 @@
       </p:sp>
       <p:sp>
         <p:nvSpPr>
-          <p:cNvPr id="12" name="Rectangle 11"/>
+          <p:cNvPr id="12" name="Rounded Rectangle 11"/>
           <p:cNvSpPr/>
           <p:nvPr/>
         </p:nvSpPr>
         <p:spPr>
           <a:xfrm>
-            <a:off x="4425696" y="1911095"/>
-            <a:ext cx="3566160" cy="1965960"/>
-          </a:xfrm>
-          <a:prstGeom prst="rect">
-            <a:avLst/>
+            <a:off x="4425696" y="1819656"/>
+            <a:ext cx="3566160" cy="2057400"/>
+          </a:xfrm>
+          <a:prstGeom prst="roundRect">
+            <a:avLst>
+              <a:gd name="adj" fmla="val 6000"/>
+            </a:avLst>
           </a:prstGeom>
           <a:solidFill>
             <a:srgbClr val="D5C9B4"/>
@@ -5095,17 +5115,19 @@
       </p:sp>
       <p:sp>
         <p:nvSpPr>
-          <p:cNvPr id="13" name="Rectangle 12"/>
+          <p:cNvPr id="13" name="Rounded Rectangle 12"/>
           <p:cNvSpPr/>
           <p:nvPr/>
         </p:nvSpPr>
         <p:spPr>
           <a:xfrm>
-            <a:off x="4389120" y="1874519"/>
-            <a:ext cx="3566160" cy="1965960"/>
-          </a:xfrm>
-          <a:prstGeom prst="rect">
-            <a:avLst/>
+            <a:off x="4389120" y="1783080"/>
+            <a:ext cx="3566160" cy="2057400"/>
+          </a:xfrm>
+          <a:prstGeom prst="roundRect">
+            <a:avLst>
+              <a:gd name="adj" fmla="val 6000"/>
+            </a:avLst>
           </a:prstGeom>
           <a:solidFill>
             <a:srgbClr val="FFFFFF"/>
@@ -5141,17 +5163,19 @@
       </p:sp>
       <p:sp>
         <p:nvSpPr>
-          <p:cNvPr id="14" name="Rectangle 13"/>
+          <p:cNvPr id="14" name="Rounded Rectangle 13"/>
           <p:cNvSpPr/>
           <p:nvPr/>
         </p:nvSpPr>
         <p:spPr>
           <a:xfrm>
-            <a:off x="4663440" y="2148839"/>
+            <a:off x="4663440" y="2057400"/>
             <a:ext cx="365760" cy="365760"/>
           </a:xfrm>
-          <a:prstGeom prst="rect">
-            <a:avLst/>
+          <a:prstGeom prst="roundRect">
+            <a:avLst>
+              <a:gd name="adj" fmla="val 20000"/>
+            </a:avLst>
           </a:prstGeom>
           <a:solidFill>
             <a:srgbClr val="2D4A3E"/>
@@ -5191,7 +5215,7 @@
         </p:nvSpPr>
         <p:spPr>
           <a:xfrm>
-            <a:off x="5166359" y="2148839"/>
+            <a:off x="5166359" y="2057400"/>
             <a:ext cx="2560320" cy="411480"/>
           </a:xfrm>
           <a:prstGeom prst="rect">
@@ -5207,7 +5231,7 @@
           <a:p>
             <a:pPr algn="l"/>
             <a:r>
-              <a:rPr sz="1250">
+              <a:rPr sz="1600">
                 <a:solidFill>
                   <a:srgbClr val="2C2418"/>
                 </a:solidFill>
@@ -5227,8 +5251,8 @@
         </p:nvSpPr>
         <p:spPr>
           <a:xfrm>
-            <a:off x="4663440" y="2743200"/>
-            <a:ext cx="3017520" cy="960119"/>
+            <a:off x="4663440" y="2651760"/>
+            <a:ext cx="3017520" cy="1051560"/>
           </a:xfrm>
           <a:prstGeom prst="rect">
             <a:avLst/>
@@ -5247,7 +5271,7 @@
               </a:lnSpc>
             </a:pPr>
             <a:r>
-              <a:rPr sz="1100">
+              <a:rPr sz="1400">
                 <a:solidFill>
                   <a:srgbClr val="6B6356"/>
                 </a:solidFill>
@@ -5261,17 +5285,19 @@
       </p:sp>
       <p:sp>
         <p:nvSpPr>
-          <p:cNvPr id="17" name="Rectangle 16"/>
+          <p:cNvPr id="17" name="Rounded Rectangle 16"/>
           <p:cNvSpPr/>
           <p:nvPr/>
         </p:nvSpPr>
         <p:spPr>
           <a:xfrm>
-            <a:off x="8174735" y="1911095"/>
-            <a:ext cx="3566160" cy="1965960"/>
-          </a:xfrm>
-          <a:prstGeom prst="rect">
-            <a:avLst/>
+            <a:off x="8174735" y="1819656"/>
+            <a:ext cx="3566160" cy="2057400"/>
+          </a:xfrm>
+          <a:prstGeom prst="roundRect">
+            <a:avLst>
+              <a:gd name="adj" fmla="val 6000"/>
+            </a:avLst>
           </a:prstGeom>
           <a:solidFill>
             <a:srgbClr val="D5C9B4"/>
@@ -5305,17 +5331,19 @@
       </p:sp>
       <p:sp>
         <p:nvSpPr>
-          <p:cNvPr id="18" name="Rectangle 17"/>
+          <p:cNvPr id="18" name="Rounded Rectangle 17"/>
           <p:cNvSpPr/>
           <p:nvPr/>
         </p:nvSpPr>
         <p:spPr>
           <a:xfrm>
-            <a:off x="8138159" y="1874519"/>
-            <a:ext cx="3566160" cy="1965960"/>
-          </a:xfrm>
-          <a:prstGeom prst="rect">
-            <a:avLst/>
+            <a:off x="8138159" y="1783080"/>
+            <a:ext cx="3566160" cy="2057400"/>
+          </a:xfrm>
+          <a:prstGeom prst="roundRect">
+            <a:avLst>
+              <a:gd name="adj" fmla="val 6000"/>
+            </a:avLst>
           </a:prstGeom>
           <a:solidFill>
             <a:srgbClr val="FFFFFF"/>
@@ -5351,17 +5379,19 @@
       </p:sp>
       <p:sp>
         <p:nvSpPr>
-          <p:cNvPr id="19" name="Rectangle 18"/>
+          <p:cNvPr id="19" name="Rounded Rectangle 18"/>
           <p:cNvSpPr/>
           <p:nvPr/>
         </p:nvSpPr>
         <p:spPr>
           <a:xfrm>
-            <a:off x="8412480" y="2148839"/>
+            <a:off x="8412480" y="2057400"/>
             <a:ext cx="365760" cy="365760"/>
           </a:xfrm>
-          <a:prstGeom prst="rect">
-            <a:avLst/>
+          <a:prstGeom prst="roundRect">
+            <a:avLst>
+              <a:gd name="adj" fmla="val 20000"/>
+            </a:avLst>
           </a:prstGeom>
           <a:solidFill>
             <a:srgbClr val="2D4A3E"/>
@@ -5401,7 +5431,7 @@
         </p:nvSpPr>
         <p:spPr>
           <a:xfrm>
-            <a:off x="8915399" y="2148839"/>
+            <a:off x="8915399" y="2057400"/>
             <a:ext cx="2560320" cy="411480"/>
           </a:xfrm>
           <a:prstGeom prst="rect">
@@ -5417,7 +5447,7 @@
           <a:p>
             <a:pPr algn="l"/>
             <a:r>
-              <a:rPr sz="1250">
+              <a:rPr sz="1600">
                 <a:solidFill>
                   <a:srgbClr val="2C2418"/>
                 </a:solidFill>
@@ -5437,8 +5467,8 @@
         </p:nvSpPr>
         <p:spPr>
           <a:xfrm>
-            <a:off x="8412480" y="2743200"/>
-            <a:ext cx="3017520" cy="960119"/>
+            <a:off x="8412480" y="2651760"/>
+            <a:ext cx="3017520" cy="1051560"/>
           </a:xfrm>
           <a:prstGeom prst="rect">
             <a:avLst/>
@@ -5457,7 +5487,7 @@
               </a:lnSpc>
             </a:pPr>
             <a:r>
-              <a:rPr sz="1100">
+              <a:rPr sz="1400">
                 <a:solidFill>
                   <a:srgbClr val="6B6356"/>
                 </a:solidFill>
@@ -5471,17 +5501,19 @@
       </p:sp>
       <p:sp>
         <p:nvSpPr>
-          <p:cNvPr id="22" name="Rectangle 21"/>
+          <p:cNvPr id="22" name="Rounded Rectangle 21"/>
           <p:cNvSpPr/>
           <p:nvPr/>
         </p:nvSpPr>
         <p:spPr>
           <a:xfrm>
-            <a:off x="676656" y="4105655"/>
-            <a:ext cx="3566160" cy="1965960"/>
-          </a:xfrm>
-          <a:prstGeom prst="rect">
-            <a:avLst/>
+            <a:off x="676656" y="4105656"/>
+            <a:ext cx="3566160" cy="2057400"/>
+          </a:xfrm>
+          <a:prstGeom prst="roundRect">
+            <a:avLst>
+              <a:gd name="adj" fmla="val 6000"/>
+            </a:avLst>
           </a:prstGeom>
           <a:solidFill>
             <a:srgbClr val="D5C9B4"/>
@@ -5515,17 +5547,19 @@
       </p:sp>
       <p:sp>
         <p:nvSpPr>
-          <p:cNvPr id="23" name="Rectangle 22"/>
+          <p:cNvPr id="23" name="Rounded Rectangle 22"/>
           <p:cNvSpPr/>
           <p:nvPr/>
         </p:nvSpPr>
         <p:spPr>
           <a:xfrm>
-            <a:off x="640080" y="4069079"/>
-            <a:ext cx="3566160" cy="1965960"/>
-          </a:xfrm>
-          <a:prstGeom prst="rect">
-            <a:avLst/>
+            <a:off x="640080" y="4069080"/>
+            <a:ext cx="3566160" cy="2057400"/>
+          </a:xfrm>
+          <a:prstGeom prst="roundRect">
+            <a:avLst>
+              <a:gd name="adj" fmla="val 6000"/>
+            </a:avLst>
           </a:prstGeom>
           <a:solidFill>
             <a:srgbClr val="FFFFFF"/>
@@ -5561,17 +5595,19 @@
       </p:sp>
       <p:sp>
         <p:nvSpPr>
-          <p:cNvPr id="24" name="Rectangle 23"/>
+          <p:cNvPr id="24" name="Rounded Rectangle 23"/>
           <p:cNvSpPr/>
           <p:nvPr/>
         </p:nvSpPr>
         <p:spPr>
           <a:xfrm>
-            <a:off x="914400" y="4343399"/>
+            <a:off x="914400" y="4343400"/>
             <a:ext cx="365760" cy="365760"/>
           </a:xfrm>
-          <a:prstGeom prst="rect">
-            <a:avLst/>
+          <a:prstGeom prst="roundRect">
+            <a:avLst>
+              <a:gd name="adj" fmla="val 20000"/>
+            </a:avLst>
           </a:prstGeom>
           <a:solidFill>
             <a:srgbClr val="2D4A3E"/>
@@ -5611,7 +5647,7 @@
         </p:nvSpPr>
         <p:spPr>
           <a:xfrm>
-            <a:off x="1417319" y="4343399"/>
+            <a:off x="1417319" y="4343400"/>
             <a:ext cx="2560320" cy="411480"/>
           </a:xfrm>
           <a:prstGeom prst="rect">
@@ -5627,7 +5663,7 @@
           <a:p>
             <a:pPr algn="l"/>
             <a:r>
-              <a:rPr sz="1250">
+              <a:rPr sz="1600">
                 <a:solidFill>
                   <a:srgbClr val="2C2418"/>
                 </a:solidFill>
@@ -5647,8 +5683,8 @@
         </p:nvSpPr>
         <p:spPr>
           <a:xfrm>
-            <a:off x="914400" y="4937759"/>
-            <a:ext cx="3017520" cy="960119"/>
+            <a:off x="914400" y="4937760"/>
+            <a:ext cx="3017520" cy="1051560"/>
           </a:xfrm>
           <a:prstGeom prst="rect">
             <a:avLst/>
@@ -5667,7 +5703,7 @@
               </a:lnSpc>
             </a:pPr>
             <a:r>
-              <a:rPr sz="1100">
+              <a:rPr sz="1400">
                 <a:solidFill>
                   <a:srgbClr val="6B6356"/>
                 </a:solidFill>
@@ -5681,17 +5717,19 @@
       </p:sp>
       <p:sp>
         <p:nvSpPr>
-          <p:cNvPr id="27" name="Rectangle 26"/>
+          <p:cNvPr id="27" name="Rounded Rectangle 26"/>
           <p:cNvSpPr/>
           <p:nvPr/>
         </p:nvSpPr>
         <p:spPr>
           <a:xfrm>
-            <a:off x="4425696" y="4105655"/>
-            <a:ext cx="3566160" cy="1965960"/>
-          </a:xfrm>
-          <a:prstGeom prst="rect">
-            <a:avLst/>
+            <a:off x="4425696" y="4105656"/>
+            <a:ext cx="3566160" cy="2057400"/>
+          </a:xfrm>
+          <a:prstGeom prst="roundRect">
+            <a:avLst>
+              <a:gd name="adj" fmla="val 6000"/>
+            </a:avLst>
           </a:prstGeom>
           <a:solidFill>
             <a:srgbClr val="D5C9B4"/>
@@ -5725,17 +5763,19 @@
       </p:sp>
       <p:sp>
         <p:nvSpPr>
-          <p:cNvPr id="28" name="Rectangle 27"/>
+          <p:cNvPr id="28" name="Rounded Rectangle 27"/>
           <p:cNvSpPr/>
           <p:nvPr/>
         </p:nvSpPr>
         <p:spPr>
           <a:xfrm>
-            <a:off x="4389120" y="4069079"/>
-            <a:ext cx="3566160" cy="1965960"/>
-          </a:xfrm>
-          <a:prstGeom prst="rect">
-            <a:avLst/>
+            <a:off x="4389120" y="4069080"/>
+            <a:ext cx="3566160" cy="2057400"/>
+          </a:xfrm>
+          <a:prstGeom prst="roundRect">
+            <a:avLst>
+              <a:gd name="adj" fmla="val 6000"/>
+            </a:avLst>
           </a:prstGeom>
           <a:solidFill>
             <a:srgbClr val="FFFFFF"/>
@@ -5771,17 +5811,19 @@
       </p:sp>
       <p:sp>
         <p:nvSpPr>
-          <p:cNvPr id="29" name="Rectangle 28"/>
+          <p:cNvPr id="29" name="Rounded Rectangle 28"/>
           <p:cNvSpPr/>
           <p:nvPr/>
         </p:nvSpPr>
         <p:spPr>
           <a:xfrm>
-            <a:off x="4663440" y="4343399"/>
+            <a:off x="4663440" y="4343400"/>
             <a:ext cx="365760" cy="365760"/>
           </a:xfrm>
-          <a:prstGeom prst="rect">
-            <a:avLst/>
+          <a:prstGeom prst="roundRect">
+            <a:avLst>
+              <a:gd name="adj" fmla="val 20000"/>
+            </a:avLst>
           </a:prstGeom>
           <a:solidFill>
             <a:srgbClr val="2D4A3E"/>
@@ -5821,7 +5863,7 @@
         </p:nvSpPr>
         <p:spPr>
           <a:xfrm>
-            <a:off x="5166359" y="4343399"/>
+            <a:off x="5166359" y="4343400"/>
             <a:ext cx="2560320" cy="411480"/>
           </a:xfrm>
           <a:prstGeom prst="rect">
@@ -5837,7 +5879,7 @@
           <a:p>
             <a:pPr algn="l"/>
             <a:r>
-              <a:rPr sz="1250">
+              <a:rPr sz="1600">
                 <a:solidFill>
                   <a:srgbClr val="2C2418"/>
                 </a:solidFill>
@@ -5857,8 +5899,8 @@
         </p:nvSpPr>
         <p:spPr>
           <a:xfrm>
-            <a:off x="4663440" y="4937759"/>
-            <a:ext cx="3017520" cy="960119"/>
+            <a:off x="4663440" y="4937760"/>
+            <a:ext cx="3017520" cy="1051560"/>
           </a:xfrm>
           <a:prstGeom prst="rect">
             <a:avLst/>
@@ -5877,7 +5919,7 @@
               </a:lnSpc>
             </a:pPr>
             <a:r>
-              <a:rPr sz="1100">
+              <a:rPr sz="1400">
                 <a:solidFill>
                   <a:srgbClr val="6B6356"/>
                 </a:solidFill>
@@ -5891,17 +5933,19 @@
       </p:sp>
       <p:sp>
         <p:nvSpPr>
-          <p:cNvPr id="32" name="Rectangle 31"/>
+          <p:cNvPr id="32" name="Rounded Rectangle 31"/>
           <p:cNvSpPr/>
           <p:nvPr/>
         </p:nvSpPr>
         <p:spPr>
           <a:xfrm>
-            <a:off x="8174735" y="4105655"/>
-            <a:ext cx="3566160" cy="1965960"/>
-          </a:xfrm>
-          <a:prstGeom prst="rect">
-            <a:avLst/>
+            <a:off x="8174735" y="4105656"/>
+            <a:ext cx="3566160" cy="2057400"/>
+          </a:xfrm>
+          <a:prstGeom prst="roundRect">
+            <a:avLst>
+              <a:gd name="adj" fmla="val 6000"/>
+            </a:avLst>
           </a:prstGeom>
           <a:solidFill>
             <a:srgbClr val="D5C9B4"/>
@@ -5935,17 +5979,19 @@
       </p:sp>
       <p:sp>
         <p:nvSpPr>
-          <p:cNvPr id="33" name="Rectangle 32"/>
+          <p:cNvPr id="33" name="Rounded Rectangle 32"/>
           <p:cNvSpPr/>
           <p:nvPr/>
         </p:nvSpPr>
         <p:spPr>
           <a:xfrm>
-            <a:off x="8138159" y="4069079"/>
-            <a:ext cx="3566160" cy="1965960"/>
-          </a:xfrm>
-          <a:prstGeom prst="rect">
-            <a:avLst/>
+            <a:off x="8138159" y="4069080"/>
+            <a:ext cx="3566160" cy="2057400"/>
+          </a:xfrm>
+          <a:prstGeom prst="roundRect">
+            <a:avLst>
+              <a:gd name="adj" fmla="val 6000"/>
+            </a:avLst>
           </a:prstGeom>
           <a:solidFill>
             <a:srgbClr val="FFFFFF"/>
@@ -5981,17 +6027,19 @@
       </p:sp>
       <p:sp>
         <p:nvSpPr>
-          <p:cNvPr id="34" name="Rectangle 33"/>
+          <p:cNvPr id="34" name="Rounded Rectangle 33"/>
           <p:cNvSpPr/>
           <p:nvPr/>
         </p:nvSpPr>
         <p:spPr>
           <a:xfrm>
-            <a:off x="8412480" y="4343399"/>
+            <a:off x="8412480" y="4343400"/>
             <a:ext cx="365760" cy="365760"/>
           </a:xfrm>
-          <a:prstGeom prst="rect">
-            <a:avLst/>
+          <a:prstGeom prst="roundRect">
+            <a:avLst>
+              <a:gd name="adj" fmla="val 20000"/>
+            </a:avLst>
           </a:prstGeom>
           <a:solidFill>
             <a:srgbClr val="2D4A3E"/>
@@ -6031,7 +6079,7 @@
         </p:nvSpPr>
         <p:spPr>
           <a:xfrm>
-            <a:off x="8915399" y="4343399"/>
+            <a:off x="8915399" y="4343400"/>
             <a:ext cx="2560320" cy="411480"/>
           </a:xfrm>
           <a:prstGeom prst="rect">
@@ -6047,7 +6095,7 @@
           <a:p>
             <a:pPr algn="l"/>
             <a:r>
-              <a:rPr sz="1250">
+              <a:rPr sz="1600">
                 <a:solidFill>
                   <a:srgbClr val="2C2418"/>
                 </a:solidFill>
@@ -6067,8 +6115,8 @@
         </p:nvSpPr>
         <p:spPr>
           <a:xfrm>
-            <a:off x="8412480" y="4937759"/>
-            <a:ext cx="3017520" cy="960119"/>
+            <a:off x="8412480" y="4937760"/>
+            <a:ext cx="3017520" cy="1051560"/>
           </a:xfrm>
           <a:prstGeom prst="rect">
             <a:avLst/>
@@ -6087,7 +6135,7 @@
               </a:lnSpc>
             </a:pPr>
             <a:r>
-              <a:rPr sz="1100">
+              <a:rPr sz="1400">
                 <a:solidFill>
                   <a:srgbClr val="6B6356"/>
                 </a:solidFill>
@@ -6241,7 +6289,7 @@
         </p:nvSpPr>
         <p:spPr>
           <a:xfrm>
-            <a:off x="640080" y="1600200"/>
+            <a:off x="640080" y="1481328"/>
             <a:ext cx="10881360" cy="13716"/>
           </a:xfrm>
           <a:prstGeom prst="rect">
@@ -6301,7 +6349,7 @@
           <a:p>
             <a:pPr algn="r"/>
             <a:r>
-              <a:rPr sz="900">
+              <a:rPr sz="1150">
                 <a:solidFill>
                   <a:srgbClr val="9B9182"/>
                 </a:solidFill>
@@ -6321,8 +6369,8 @@
         </p:nvSpPr>
         <p:spPr>
           <a:xfrm>
-            <a:off x="640080" y="2011680"/>
-            <a:ext cx="2743200" cy="274320"/>
+            <a:off x="640080" y="1874519"/>
+            <a:ext cx="3657600" cy="274320"/>
           </a:xfrm>
           <a:prstGeom prst="rect">
             <a:avLst/>
@@ -6337,7 +6385,7 @@
           <a:p>
             <a:pPr algn="l"/>
             <a:r>
-              <a:rPr sz="1000">
+              <a:rPr sz="1300">
                 <a:solidFill>
                   <a:srgbClr val="8B2635"/>
                 </a:solidFill>
@@ -6357,7 +6405,7 @@
         </p:nvSpPr>
         <p:spPr>
           <a:xfrm>
-            <a:off x="640080" y="2331720"/>
+            <a:off x="640080" y="2240280"/>
             <a:ext cx="10881360" cy="548640"/>
           </a:xfrm>
           <a:prstGeom prst="rect">
@@ -6377,7 +6425,7 @@
               </a:lnSpc>
             </a:pPr>
             <a:r>
-              <a:rPr sz="1300">
+              <a:rPr sz="1700">
                 <a:solidFill>
                   <a:srgbClr val="2C2418"/>
                 </a:solidFill>
@@ -6397,7 +6445,7 @@
         </p:nvSpPr>
         <p:spPr>
           <a:xfrm>
-            <a:off x="640080" y="3246120"/>
+            <a:off x="640080" y="3108960"/>
             <a:ext cx="4572000" cy="274320"/>
           </a:xfrm>
           <a:prstGeom prst="rect">
@@ -6413,7 +6461,7 @@
           <a:p>
             <a:pPr algn="l"/>
             <a:r>
-              <a:rPr sz="1000">
+              <a:rPr sz="1300">
                 <a:solidFill>
                   <a:srgbClr val="2D4A3E"/>
                 </a:solidFill>
@@ -6427,17 +6475,19 @@
       </p:sp>
       <p:sp>
         <p:nvSpPr>
-          <p:cNvPr id="10" name="Rectangle 9"/>
+          <p:cNvPr id="10" name="Rounded Rectangle 9"/>
           <p:cNvSpPr/>
           <p:nvPr/>
         </p:nvSpPr>
         <p:spPr>
           <a:xfrm>
-            <a:off x="676656" y="3648456"/>
-            <a:ext cx="2103120" cy="1051560"/>
-          </a:xfrm>
-          <a:prstGeom prst="rect">
-            <a:avLst/>
+            <a:off x="676656" y="3557016"/>
+            <a:ext cx="2103120" cy="1143000"/>
+          </a:xfrm>
+          <a:prstGeom prst="roundRect">
+            <a:avLst>
+              <a:gd name="adj" fmla="val 6000"/>
+            </a:avLst>
           </a:prstGeom>
           <a:solidFill>
             <a:srgbClr val="D5C9B4"/>
@@ -6471,17 +6521,19 @@
       </p:sp>
       <p:sp>
         <p:nvSpPr>
-          <p:cNvPr id="11" name="Rectangle 10"/>
+          <p:cNvPr id="11" name="Rounded Rectangle 10"/>
           <p:cNvSpPr/>
           <p:nvPr/>
         </p:nvSpPr>
         <p:spPr>
           <a:xfrm>
-            <a:off x="640080" y="3611880"/>
-            <a:ext cx="2103120" cy="1051560"/>
-          </a:xfrm>
-          <a:prstGeom prst="rect">
-            <a:avLst/>
+            <a:off x="640080" y="3520440"/>
+            <a:ext cx="2103120" cy="1143000"/>
+          </a:xfrm>
+          <a:prstGeom prst="roundRect">
+            <a:avLst>
+              <a:gd name="adj" fmla="val 6000"/>
+            </a:avLst>
           </a:prstGeom>
           <a:solidFill>
             <a:srgbClr val="FFFFFF"/>
@@ -6523,7 +6575,7 @@
         </p:nvSpPr>
         <p:spPr>
           <a:xfrm>
-            <a:off x="640080" y="3794760"/>
+            <a:off x="640080" y="3703320"/>
             <a:ext cx="2103120" cy="365760"/>
           </a:xfrm>
           <a:prstGeom prst="rect">
@@ -6539,7 +6591,7 @@
           <a:p>
             <a:pPr algn="ctr"/>
             <a:r>
-              <a:rPr sz="1200">
+              <a:rPr sz="1550">
                 <a:solidFill>
                   <a:srgbClr val="2D4A3E"/>
                 </a:solidFill>
@@ -6559,8 +6611,8 @@
         </p:nvSpPr>
         <p:spPr>
           <a:xfrm>
-            <a:off x="640080" y="4160520"/>
-            <a:ext cx="2103120" cy="457199"/>
+            <a:off x="640080" y="4069080"/>
+            <a:ext cx="2103120" cy="548640"/>
           </a:xfrm>
           <a:prstGeom prst="rect">
             <a:avLst/>
@@ -6579,7 +6631,7 @@
               </a:lnSpc>
             </a:pPr>
             <a:r>
-              <a:rPr sz="900">
+              <a:rPr sz="1200">
                 <a:solidFill>
                   <a:srgbClr val="6B6356"/>
                 </a:solidFill>
@@ -6637,17 +6689,19 @@
       </p:sp>
       <p:sp>
         <p:nvSpPr>
-          <p:cNvPr id="15" name="Rectangle 14"/>
+          <p:cNvPr id="15" name="Rounded Rectangle 14"/>
           <p:cNvSpPr/>
           <p:nvPr/>
         </p:nvSpPr>
         <p:spPr>
           <a:xfrm>
-            <a:off x="2889504" y="3648456"/>
-            <a:ext cx="2103120" cy="1051560"/>
-          </a:xfrm>
-          <a:prstGeom prst="rect">
-            <a:avLst/>
+            <a:off x="2889504" y="3557016"/>
+            <a:ext cx="2103120" cy="1143000"/>
+          </a:xfrm>
+          <a:prstGeom prst="roundRect">
+            <a:avLst>
+              <a:gd name="adj" fmla="val 6000"/>
+            </a:avLst>
           </a:prstGeom>
           <a:solidFill>
             <a:srgbClr val="D5C9B4"/>
@@ -6681,17 +6735,19 @@
       </p:sp>
       <p:sp>
         <p:nvSpPr>
-          <p:cNvPr id="16" name="Rectangle 15"/>
+          <p:cNvPr id="16" name="Rounded Rectangle 15"/>
           <p:cNvSpPr/>
           <p:nvPr/>
         </p:nvSpPr>
         <p:spPr>
           <a:xfrm>
-            <a:off x="2852928" y="3611880"/>
-            <a:ext cx="2103120" cy="1051560"/>
-          </a:xfrm>
-          <a:prstGeom prst="rect">
-            <a:avLst/>
+            <a:off x="2852928" y="3520440"/>
+            <a:ext cx="2103120" cy="1143000"/>
+          </a:xfrm>
+          <a:prstGeom prst="roundRect">
+            <a:avLst>
+              <a:gd name="adj" fmla="val 6000"/>
+            </a:avLst>
           </a:prstGeom>
           <a:solidFill>
             <a:srgbClr val="FFFFFF"/>
@@ -6733,7 +6789,7 @@
         </p:nvSpPr>
         <p:spPr>
           <a:xfrm>
-            <a:off x="2852928" y="3794760"/>
+            <a:off x="2852928" y="3703320"/>
             <a:ext cx="2103120" cy="365760"/>
           </a:xfrm>
           <a:prstGeom prst="rect">
@@ -6749,7 +6805,7 @@
           <a:p>
             <a:pPr algn="ctr"/>
             <a:r>
-              <a:rPr sz="1200">
+              <a:rPr sz="1550">
                 <a:solidFill>
                   <a:srgbClr val="2D4A3E"/>
                 </a:solidFill>
@@ -6769,8 +6825,8 @@
         </p:nvSpPr>
         <p:spPr>
           <a:xfrm>
-            <a:off x="2852928" y="4160520"/>
-            <a:ext cx="2103120" cy="457199"/>
+            <a:off x="2852928" y="4069080"/>
+            <a:ext cx="2103120" cy="548640"/>
           </a:xfrm>
           <a:prstGeom prst="rect">
             <a:avLst/>
@@ -6789,7 +6845,7 @@
               </a:lnSpc>
             </a:pPr>
             <a:r>
-              <a:rPr sz="900">
+              <a:rPr sz="1200">
                 <a:solidFill>
                   <a:srgbClr val="6B6356"/>
                 </a:solidFill>
@@ -6847,17 +6903,19 @@
       </p:sp>
       <p:sp>
         <p:nvSpPr>
-          <p:cNvPr id="20" name="Rectangle 19"/>
+          <p:cNvPr id="20" name="Rounded Rectangle 19"/>
           <p:cNvSpPr/>
           <p:nvPr/>
         </p:nvSpPr>
         <p:spPr>
           <a:xfrm>
-            <a:off x="5102352" y="3648456"/>
-            <a:ext cx="2103120" cy="1051560"/>
-          </a:xfrm>
-          <a:prstGeom prst="rect">
-            <a:avLst/>
+            <a:off x="5102352" y="3557016"/>
+            <a:ext cx="2103120" cy="1143000"/>
+          </a:xfrm>
+          <a:prstGeom prst="roundRect">
+            <a:avLst>
+              <a:gd name="adj" fmla="val 6000"/>
+            </a:avLst>
           </a:prstGeom>
           <a:solidFill>
             <a:srgbClr val="D5C9B4"/>
@@ -6891,17 +6949,19 @@
       </p:sp>
       <p:sp>
         <p:nvSpPr>
-          <p:cNvPr id="21" name="Rectangle 20"/>
+          <p:cNvPr id="21" name="Rounded Rectangle 20"/>
           <p:cNvSpPr/>
           <p:nvPr/>
         </p:nvSpPr>
         <p:spPr>
           <a:xfrm>
-            <a:off x="5065776" y="3611880"/>
-            <a:ext cx="2103120" cy="1051560"/>
-          </a:xfrm>
-          <a:prstGeom prst="rect">
-            <a:avLst/>
+            <a:off x="5065776" y="3520440"/>
+            <a:ext cx="2103120" cy="1143000"/>
+          </a:xfrm>
+          <a:prstGeom prst="roundRect">
+            <a:avLst>
+              <a:gd name="adj" fmla="val 6000"/>
+            </a:avLst>
           </a:prstGeom>
           <a:solidFill>
             <a:srgbClr val="FFFFFF"/>
@@ -6943,7 +7003,7 @@
         </p:nvSpPr>
         <p:spPr>
           <a:xfrm>
-            <a:off x="5065776" y="3794760"/>
+            <a:off x="5065776" y="3703320"/>
             <a:ext cx="2103120" cy="365760"/>
           </a:xfrm>
           <a:prstGeom prst="rect">
@@ -6959,7 +7019,7 @@
           <a:p>
             <a:pPr algn="ctr"/>
             <a:r>
-              <a:rPr sz="1200">
+              <a:rPr sz="1550">
                 <a:solidFill>
                   <a:srgbClr val="2D4A3E"/>
                 </a:solidFill>
@@ -6979,8 +7039,8 @@
         </p:nvSpPr>
         <p:spPr>
           <a:xfrm>
-            <a:off x="5065776" y="4160520"/>
-            <a:ext cx="2103120" cy="457199"/>
+            <a:off x="5065776" y="4069080"/>
+            <a:ext cx="2103120" cy="548640"/>
           </a:xfrm>
           <a:prstGeom prst="rect">
             <a:avLst/>
@@ -6999,7 +7059,7 @@
               </a:lnSpc>
             </a:pPr>
             <a:r>
-              <a:rPr sz="900">
+              <a:rPr sz="1200">
                 <a:solidFill>
                   <a:srgbClr val="6B6356"/>
                 </a:solidFill>
@@ -7058,17 +7118,19 @@
       </p:sp>
       <p:sp>
         <p:nvSpPr>
-          <p:cNvPr id="25" name="Rectangle 24"/>
+          <p:cNvPr id="25" name="Rounded Rectangle 24"/>
           <p:cNvSpPr/>
           <p:nvPr/>
         </p:nvSpPr>
         <p:spPr>
           <a:xfrm>
-            <a:off x="7315200" y="3648456"/>
-            <a:ext cx="2103120" cy="1051560"/>
-          </a:xfrm>
-          <a:prstGeom prst="rect">
-            <a:avLst/>
+            <a:off x="7315200" y="3557016"/>
+            <a:ext cx="2103120" cy="1143000"/>
+          </a:xfrm>
+          <a:prstGeom prst="roundRect">
+            <a:avLst>
+              <a:gd name="adj" fmla="val 6000"/>
+            </a:avLst>
           </a:prstGeom>
           <a:solidFill>
             <a:srgbClr val="D5C9B4"/>
@@ -7102,17 +7164,19 @@
       </p:sp>
       <p:sp>
         <p:nvSpPr>
-          <p:cNvPr id="26" name="Rectangle 25"/>
+          <p:cNvPr id="26" name="Rounded Rectangle 25"/>
           <p:cNvSpPr/>
           <p:nvPr/>
         </p:nvSpPr>
         <p:spPr>
           <a:xfrm>
-            <a:off x="7278624" y="3611880"/>
-            <a:ext cx="2103120" cy="1051560"/>
-          </a:xfrm>
-          <a:prstGeom prst="rect">
-            <a:avLst/>
+            <a:off x="7278624" y="3520440"/>
+            <a:ext cx="2103120" cy="1143000"/>
+          </a:xfrm>
+          <a:prstGeom prst="roundRect">
+            <a:avLst>
+              <a:gd name="adj" fmla="val 6000"/>
+            </a:avLst>
           </a:prstGeom>
           <a:solidFill>
             <a:srgbClr val="FFFFFF"/>
@@ -7154,7 +7218,7 @@
         </p:nvSpPr>
         <p:spPr>
           <a:xfrm>
-            <a:off x="7278624" y="3794760"/>
+            <a:off x="7278624" y="3703320"/>
             <a:ext cx="2103120" cy="365760"/>
           </a:xfrm>
           <a:prstGeom prst="rect">
@@ -7170,7 +7234,7 @@
           <a:p>
             <a:pPr algn="ctr"/>
             <a:r>
-              <a:rPr sz="1200">
+              <a:rPr sz="1550">
                 <a:solidFill>
                   <a:srgbClr val="2D4A3E"/>
                 </a:solidFill>
@@ -7190,8 +7254,8 @@
         </p:nvSpPr>
         <p:spPr>
           <a:xfrm>
-            <a:off x="7278624" y="4160520"/>
-            <a:ext cx="2103120" cy="457199"/>
+            <a:off x="7278624" y="4069080"/>
+            <a:ext cx="2103120" cy="548640"/>
           </a:xfrm>
           <a:prstGeom prst="rect">
             <a:avLst/>
@@ -7210,7 +7274,7 @@
               </a:lnSpc>
             </a:pPr>
             <a:r>
-              <a:rPr sz="900">
+              <a:rPr sz="1200">
                 <a:solidFill>
                   <a:srgbClr val="6B6356"/>
                 </a:solidFill>
@@ -7269,17 +7333,19 @@
       </p:sp>
       <p:sp>
         <p:nvSpPr>
-          <p:cNvPr id="30" name="Rectangle 29"/>
+          <p:cNvPr id="30" name="Rounded Rectangle 29"/>
           <p:cNvSpPr/>
           <p:nvPr/>
         </p:nvSpPr>
         <p:spPr>
           <a:xfrm>
-            <a:off x="9528047" y="3648456"/>
-            <a:ext cx="2103120" cy="1051560"/>
-          </a:xfrm>
-          <a:prstGeom prst="rect">
-            <a:avLst/>
+            <a:off x="9528047" y="3557016"/>
+            <a:ext cx="2103120" cy="1143000"/>
+          </a:xfrm>
+          <a:prstGeom prst="roundRect">
+            <a:avLst>
+              <a:gd name="adj" fmla="val 6000"/>
+            </a:avLst>
           </a:prstGeom>
           <a:solidFill>
             <a:srgbClr val="D5C9B4"/>
@@ -7313,17 +7379,19 @@
       </p:sp>
       <p:sp>
         <p:nvSpPr>
-          <p:cNvPr id="31" name="Rectangle 30"/>
+          <p:cNvPr id="31" name="Rounded Rectangle 30"/>
           <p:cNvSpPr/>
           <p:nvPr/>
         </p:nvSpPr>
         <p:spPr>
           <a:xfrm>
-            <a:off x="9491472" y="3611880"/>
-            <a:ext cx="2103120" cy="1051560"/>
-          </a:xfrm>
-          <a:prstGeom prst="rect">
-            <a:avLst/>
+            <a:off x="9491472" y="3520440"/>
+            <a:ext cx="2103120" cy="1143000"/>
+          </a:xfrm>
+          <a:prstGeom prst="roundRect">
+            <a:avLst>
+              <a:gd name="adj" fmla="val 6000"/>
+            </a:avLst>
           </a:prstGeom>
           <a:solidFill>
             <a:srgbClr val="FFFFFF"/>
@@ -7365,7 +7433,7 @@
         </p:nvSpPr>
         <p:spPr>
           <a:xfrm>
-            <a:off x="9491472" y="3794760"/>
+            <a:off x="9491472" y="3703320"/>
             <a:ext cx="2103120" cy="365760"/>
           </a:xfrm>
           <a:prstGeom prst="rect">
@@ -7381,7 +7449,7 @@
           <a:p>
             <a:pPr algn="ctr"/>
             <a:r>
-              <a:rPr sz="1200">
+              <a:rPr sz="1550">
                 <a:solidFill>
                   <a:srgbClr val="2D4A3E"/>
                 </a:solidFill>
@@ -7401,8 +7469,8 @@
         </p:nvSpPr>
         <p:spPr>
           <a:xfrm>
-            <a:off x="9491472" y="4160520"/>
-            <a:ext cx="2103120" cy="457199"/>
+            <a:off x="9491472" y="4069080"/>
+            <a:ext cx="2103120" cy="548640"/>
           </a:xfrm>
           <a:prstGeom prst="rect">
             <a:avLst/>
@@ -7421,7 +7489,7 @@
               </a:lnSpc>
             </a:pPr>
             <a:r>
-              <a:rPr sz="900">
+              <a:rPr sz="1200">
                 <a:solidFill>
                   <a:srgbClr val="6B6356"/>
                 </a:solidFill>
@@ -7442,7 +7510,7 @@
         </p:nvSpPr>
         <p:spPr>
           <a:xfrm>
-            <a:off x="640080" y="4937760"/>
+            <a:off x="640080" y="4983480"/>
             <a:ext cx="2743200" cy="274320"/>
           </a:xfrm>
           <a:prstGeom prst="rect">
@@ -7458,7 +7526,7 @@
           <a:p>
             <a:pPr algn="l"/>
             <a:r>
-              <a:rPr sz="1000">
+              <a:rPr sz="1300">
                 <a:solidFill>
                   <a:srgbClr val="2D4A3E"/>
                 </a:solidFill>
@@ -7472,17 +7540,19 @@
       </p:sp>
       <p:sp>
         <p:nvSpPr>
-          <p:cNvPr id="35" name="Rectangle 34"/>
+          <p:cNvPr id="35" name="Rounded Rectangle 34"/>
           <p:cNvSpPr/>
           <p:nvPr/>
         </p:nvSpPr>
         <p:spPr>
           <a:xfrm>
-            <a:off x="676656" y="5294376"/>
-            <a:ext cx="5394960" cy="1371600"/>
-          </a:xfrm>
-          <a:prstGeom prst="rect">
-            <a:avLst/>
+            <a:off x="676656" y="5385816"/>
+            <a:ext cx="5394960" cy="1280160"/>
+          </a:xfrm>
+          <a:prstGeom prst="roundRect">
+            <a:avLst>
+              <a:gd name="adj" fmla="val 6000"/>
+            </a:avLst>
           </a:prstGeom>
           <a:solidFill>
             <a:srgbClr val="D5C9B4"/>
@@ -7516,17 +7586,19 @@
       </p:sp>
       <p:sp>
         <p:nvSpPr>
-          <p:cNvPr id="36" name="Rectangle 35"/>
+          <p:cNvPr id="36" name="Rounded Rectangle 35"/>
           <p:cNvSpPr/>
           <p:nvPr/>
         </p:nvSpPr>
         <p:spPr>
           <a:xfrm>
-            <a:off x="640080" y="5257800"/>
-            <a:ext cx="5394960" cy="1371600"/>
-          </a:xfrm>
-          <a:prstGeom prst="rect">
-            <a:avLst/>
+            <a:off x="640080" y="5349240"/>
+            <a:ext cx="5394960" cy="1280160"/>
+          </a:xfrm>
+          <a:prstGeom prst="roundRect">
+            <a:avLst>
+              <a:gd name="adj" fmla="val 6000"/>
+            </a:avLst>
           </a:prstGeom>
           <a:solidFill>
             <a:srgbClr val="FFFFFF"/>
@@ -7568,7 +7640,7 @@
         </p:nvSpPr>
         <p:spPr>
           <a:xfrm>
-            <a:off x="868680" y="5440680"/>
+            <a:off x="868680" y="5486400"/>
             <a:ext cx="4937760" cy="1051560"/>
           </a:xfrm>
           <a:prstGeom prst="rect">
@@ -7584,52 +7656,54 @@
           <a:p>
             <a:pPr algn="l">
               <a:lnSpc>
-                <a:spcPct val="150000"/>
+                <a:spcPct val="145000"/>
               </a:lnSpc>
             </a:pPr>
             <a:r>
-              <a:rPr sz="1150">
+              <a:rPr sz="1500">
                 <a:solidFill>
                   <a:srgbClr val="2C2418"/>
                 </a:solidFill>
                 <a:latin typeface="맑은 고딕"/>
                 <a:ea typeface="맑은 고딕"/>
               </a:rPr>
-              <a:t>▸  홈 대시보드 — ChannelStrip, 카드 그리드, 마지막 자동 확인 시각</a:t>
+              <a:t>▸  홈 — ChannelStrip, 카드 그리드, 마지막 확인 시각</a:t>
             </a:r>
           </a:p>
           <a:p>
             <a:pPr algn="l">
               <a:lnSpc>
-                <a:spcPct val="150000"/>
+                <a:spcPct val="145000"/>
               </a:lnSpc>
             </a:pPr>
             <a:r>
-              <a:rPr sz="1150">
+              <a:rPr sz="1500">
                 <a:solidFill>
                   <a:srgbClr val="2C2418"/>
                 </a:solidFill>
                 <a:latin typeface="맑은 고딕"/>
                 <a:ea typeface="맑은 고딕"/>
               </a:rPr>
-              <a:t>▸  채널별 필터링, 최신 영상이 좌측 첫 카드부터 배치</a:t>
-            </a:r>
-          </a:p>
-        </p:txBody>
-      </p:sp>
-      <p:sp>
-        <p:nvSpPr>
-          <p:cNvPr id="38" name="Rectangle 37"/>
+              <a:t>▸  채널별 필터링, 최신 영상이 좌측 첫 카드부터</a:t>
+            </a:r>
+          </a:p>
+        </p:txBody>
+      </p:sp>
+      <p:sp>
+        <p:nvSpPr>
+          <p:cNvPr id="38" name="Rounded Rectangle 37"/>
           <p:cNvSpPr/>
           <p:nvPr/>
         </p:nvSpPr>
         <p:spPr>
           <a:xfrm>
-            <a:off x="6300216" y="5294376"/>
-            <a:ext cx="5394960" cy="1371600"/>
-          </a:xfrm>
-          <a:prstGeom prst="rect">
-            <a:avLst/>
+            <a:off x="6300216" y="5385816"/>
+            <a:ext cx="5394960" cy="1280160"/>
+          </a:xfrm>
+          <a:prstGeom prst="roundRect">
+            <a:avLst>
+              <a:gd name="adj" fmla="val 6000"/>
+            </a:avLst>
           </a:prstGeom>
           <a:solidFill>
             <a:srgbClr val="D5C9B4"/>
@@ -7663,17 +7737,19 @@
       </p:sp>
       <p:sp>
         <p:nvSpPr>
-          <p:cNvPr id="39" name="Rectangle 38"/>
+          <p:cNvPr id="39" name="Rounded Rectangle 38"/>
           <p:cNvSpPr/>
           <p:nvPr/>
         </p:nvSpPr>
         <p:spPr>
           <a:xfrm>
-            <a:off x="6263640" y="5257800"/>
-            <a:ext cx="5394960" cy="1371600"/>
-          </a:xfrm>
-          <a:prstGeom prst="rect">
-            <a:avLst/>
+            <a:off x="6263640" y="5349240"/>
+            <a:ext cx="5394960" cy="1280160"/>
+          </a:xfrm>
+          <a:prstGeom prst="roundRect">
+            <a:avLst>
+              <a:gd name="adj" fmla="val 6000"/>
+            </a:avLst>
           </a:prstGeom>
           <a:solidFill>
             <a:srgbClr val="FFFFFF"/>
@@ -7715,7 +7791,7 @@
         </p:nvSpPr>
         <p:spPr>
           <a:xfrm>
-            <a:off x="6492240" y="5440680"/>
+            <a:off x="6492240" y="5486400"/>
             <a:ext cx="4937760" cy="1051560"/>
           </a:xfrm>
           <a:prstGeom prst="rect">
@@ -7731,35 +7807,35 @@
           <a:p>
             <a:pPr algn="l">
               <a:lnSpc>
-                <a:spcPct val="150000"/>
+                <a:spcPct val="145000"/>
               </a:lnSpc>
             </a:pPr>
             <a:r>
-              <a:rPr sz="1150">
+              <a:rPr sz="1500">
                 <a:solidFill>
                   <a:srgbClr val="2C2418"/>
                 </a:solidFill>
                 <a:latin typeface="맑은 고딕"/>
                 <a:ea typeface="맑은 고딕"/>
               </a:rPr>
-              <a:t>▸  영상 상세 — 헤드라인 + 키워드 + 출연자 / 거론 인물</a:t>
+              <a:t>▸  상세 — 헤드라인 + 키워드 + 출연자 / 거론 인물</a:t>
             </a:r>
           </a:p>
           <a:p>
             <a:pPr algn="l">
               <a:lnSpc>
-                <a:spcPct val="150000"/>
+                <a:spcPct val="145000"/>
               </a:lnSpc>
             </a:pPr>
             <a:r>
-              <a:rPr sz="1150">
+              <a:rPr sz="1500">
                 <a:solidFill>
                   <a:srgbClr val="2C2418"/>
                 </a:solidFill>
                 <a:latin typeface="맑은 고딕"/>
                 <a:ea typeface="맑은 고딕"/>
               </a:rPr>
-              <a:t>▸  본문 안 (mm:ss) → 유튜브 그 시점 점프. 한 번 본 보고서는 삭제</a:t>
+              <a:t>▸  (mm:ss) → 유튜브 그 시점 점프. 보고서 삭제 가능</a:t>
             </a:r>
           </a:p>
         </p:txBody>
@@ -7906,7 +7982,7 @@
         </p:nvSpPr>
         <p:spPr>
           <a:xfrm>
-            <a:off x="640080" y="1600200"/>
+            <a:off x="640080" y="1481328"/>
             <a:ext cx="10881360" cy="13716"/>
           </a:xfrm>
           <a:prstGeom prst="rect">
@@ -7966,7 +8042,7 @@
           <a:p>
             <a:pPr algn="r"/>
             <a:r>
-              <a:rPr sz="900">
+              <a:rPr sz="1150">
                 <a:solidFill>
                   <a:srgbClr val="9B9182"/>
                 </a:solidFill>
@@ -7986,7 +8062,7 @@
         </p:nvSpPr>
         <p:spPr>
           <a:xfrm>
-            <a:off x="640080" y="1920240"/>
+            <a:off x="640080" y="1783080"/>
             <a:ext cx="2743200" cy="274320"/>
           </a:xfrm>
           <a:prstGeom prst="rect">
@@ -8002,7 +8078,7 @@
           <a:p>
             <a:pPr algn="l"/>
             <a:r>
-              <a:rPr sz="1000">
+              <a:rPr sz="1300">
                 <a:solidFill>
                   <a:srgbClr val="B5793E"/>
                 </a:solidFill>
@@ -8022,8 +8098,8 @@
         </p:nvSpPr>
         <p:spPr>
           <a:xfrm>
-            <a:off x="1188720" y="1920240"/>
-            <a:ext cx="7315200" cy="274320"/>
+            <a:off x="1188720" y="1783080"/>
+            <a:ext cx="7315200" cy="320040"/>
           </a:xfrm>
           <a:prstGeom prst="rect">
             <a:avLst/>
@@ -8038,7 +8114,7 @@
           <a:p>
             <a:pPr algn="l"/>
             <a:r>
-              <a:rPr sz="1150" u="sng">
+              <a:rPr sz="1500" u="sng">
                 <a:solidFill>
                   <a:srgbClr val="B5793E"/>
                 </a:solidFill>
@@ -8059,7 +8135,7 @@
         </p:nvSpPr>
         <p:spPr>
           <a:xfrm>
-            <a:off x="640080" y="2286000"/>
+            <a:off x="640080" y="2194560"/>
             <a:ext cx="10881360" cy="365760"/>
           </a:xfrm>
           <a:prstGeom prst="rect">
@@ -8075,7 +8151,7 @@
           <a:p>
             <a:pPr algn="l"/>
             <a:r>
-              <a:rPr sz="1000">
+              <a:rPr sz="1300">
                 <a:solidFill>
                   <a:srgbClr val="9B9182"/>
                 </a:solidFill>
@@ -8089,17 +8165,19 @@
       </p:sp>
       <p:sp>
         <p:nvSpPr>
-          <p:cNvPr id="10" name="Rectangle 9"/>
+          <p:cNvPr id="10" name="Rounded Rectangle 9"/>
           <p:cNvSpPr/>
           <p:nvPr/>
         </p:nvSpPr>
         <p:spPr>
           <a:xfrm>
-            <a:off x="676656" y="2825496"/>
+            <a:off x="676656" y="2734056"/>
             <a:ext cx="10881360" cy="3657600"/>
           </a:xfrm>
-          <a:prstGeom prst="rect">
-            <a:avLst/>
+          <a:prstGeom prst="roundRect">
+            <a:avLst>
+              <a:gd name="adj" fmla="val 6000"/>
+            </a:avLst>
           </a:prstGeom>
           <a:solidFill>
             <a:srgbClr val="D5C9B4"/>
@@ -8133,17 +8211,19 @@
       </p:sp>
       <p:sp>
         <p:nvSpPr>
-          <p:cNvPr id="11" name="Rectangle 10"/>
+          <p:cNvPr id="11" name="Rounded Rectangle 10"/>
           <p:cNvSpPr/>
           <p:nvPr/>
         </p:nvSpPr>
         <p:spPr>
           <a:xfrm>
-            <a:off x="640080" y="2788920"/>
+            <a:off x="640080" y="2697480"/>
             <a:ext cx="10881360" cy="3657600"/>
           </a:xfrm>
-          <a:prstGeom prst="rect">
-            <a:avLst/>
+          <a:prstGeom prst="roundRect">
+            <a:avLst>
+              <a:gd name="adj" fmla="val 6000"/>
+            </a:avLst>
           </a:prstGeom>
           <a:solidFill>
             <a:srgbClr val="FFFFFF"/>
@@ -8185,8 +8265,8 @@
         </p:nvSpPr>
         <p:spPr>
           <a:xfrm>
-            <a:off x="640080" y="4297680"/>
-            <a:ext cx="10881360" cy="365760"/>
+            <a:off x="640080" y="4206240"/>
+            <a:ext cx="10881360" cy="457200"/>
           </a:xfrm>
           <a:prstGeom prst="rect">
             <a:avLst/>
@@ -8201,7 +8281,7 @@
           <a:p>
             <a:pPr algn="ctr"/>
             <a:r>
-              <a:rPr sz="1400">
+              <a:rPr sz="1800">
                 <a:solidFill>
                   <a:srgbClr val="9B9182"/>
                 </a:solidFill>
@@ -8222,7 +8302,7 @@
         <p:spPr>
           <a:xfrm>
             <a:off x="640080" y="4663440"/>
-            <a:ext cx="10881360" cy="320040"/>
+            <a:ext cx="10881360" cy="365760"/>
           </a:xfrm>
           <a:prstGeom prst="rect">
             <a:avLst/>
@@ -8237,7 +8317,7 @@
           <a:p>
             <a:pPr algn="ctr"/>
             <a:r>
-              <a:rPr sz="1050">
+              <a:rPr sz="1400">
                 <a:solidFill>
                   <a:srgbClr val="9B9182"/>
                 </a:solidFill>
@@ -8391,7 +8471,7 @@
         </p:nvSpPr>
         <p:spPr>
           <a:xfrm>
-            <a:off x="640080" y="1600200"/>
+            <a:off x="640080" y="1481328"/>
             <a:ext cx="10881360" cy="13716"/>
           </a:xfrm>
           <a:prstGeom prst="rect">
@@ -8451,7 +8531,7 @@
           <a:p>
             <a:pPr algn="r"/>
             <a:r>
-              <a:rPr sz="900">
+              <a:rPr sz="1150">
                 <a:solidFill>
                   <a:srgbClr val="9B9182"/>
                 </a:solidFill>
@@ -8471,7 +8551,7 @@
         </p:nvSpPr>
         <p:spPr>
           <a:xfrm>
-            <a:off x="640080" y="1920240"/>
+            <a:off x="640080" y="1828800"/>
             <a:ext cx="4572000" cy="274320"/>
           </a:xfrm>
           <a:prstGeom prst="rect">
@@ -8487,7 +8567,7 @@
           <a:p>
             <a:pPr algn="l"/>
             <a:r>
-              <a:rPr sz="1000">
+              <a:rPr sz="1300">
                 <a:solidFill>
                   <a:srgbClr val="2D4A3E"/>
                 </a:solidFill>
@@ -8501,17 +8581,19 @@
       </p:sp>
       <p:sp>
         <p:nvSpPr>
-          <p:cNvPr id="8" name="Rectangle 7"/>
+          <p:cNvPr id="8" name="Rounded Rectangle 7"/>
           <p:cNvSpPr/>
           <p:nvPr/>
         </p:nvSpPr>
         <p:spPr>
           <a:xfrm>
-            <a:off x="676656" y="2322576"/>
-            <a:ext cx="2560320" cy="960120"/>
-          </a:xfrm>
-          <a:prstGeom prst="rect">
-            <a:avLst/>
+            <a:off x="676656" y="2231136"/>
+            <a:ext cx="2560320" cy="1005840"/>
+          </a:xfrm>
+          <a:prstGeom prst="roundRect">
+            <a:avLst>
+              <a:gd name="adj" fmla="val 6000"/>
+            </a:avLst>
           </a:prstGeom>
           <a:solidFill>
             <a:srgbClr val="D5C9B4"/>
@@ -8545,17 +8627,19 @@
       </p:sp>
       <p:sp>
         <p:nvSpPr>
-          <p:cNvPr id="9" name="Rectangle 8"/>
+          <p:cNvPr id="9" name="Rounded Rectangle 8"/>
           <p:cNvSpPr/>
           <p:nvPr/>
         </p:nvSpPr>
         <p:spPr>
           <a:xfrm>
-            <a:off x="640080" y="2286000"/>
-            <a:ext cx="2560320" cy="960120"/>
-          </a:xfrm>
-          <a:prstGeom prst="rect">
-            <a:avLst/>
+            <a:off x="640080" y="2194560"/>
+            <a:ext cx="2560320" cy="1005840"/>
+          </a:xfrm>
+          <a:prstGeom prst="roundRect">
+            <a:avLst>
+              <a:gd name="adj" fmla="val 6000"/>
+            </a:avLst>
           </a:prstGeom>
           <a:solidFill>
             <a:srgbClr val="FFFFFF"/>
@@ -8597,7 +8681,7 @@
         </p:nvSpPr>
         <p:spPr>
           <a:xfrm>
-            <a:off x="640080" y="2468880"/>
+            <a:off x="640080" y="2377440"/>
             <a:ext cx="2560320" cy="365760"/>
           </a:xfrm>
           <a:prstGeom prst="rect">
@@ -8613,7 +8697,7 @@
           <a:p>
             <a:pPr algn="ctr"/>
             <a:r>
-              <a:rPr sz="1200">
+              <a:rPr sz="1550">
                 <a:solidFill>
                   <a:srgbClr val="2D4A3E"/>
                 </a:solidFill>
@@ -8633,7 +8717,7 @@
         </p:nvSpPr>
         <p:spPr>
           <a:xfrm>
-            <a:off x="3236976" y="2606040"/>
+            <a:off x="3236976" y="2542032"/>
             <a:ext cx="274320" cy="329184"/>
           </a:xfrm>
           <a:prstGeom prst="rightArrow">
@@ -8671,17 +8755,19 @@
       </p:sp>
       <p:sp>
         <p:nvSpPr>
-          <p:cNvPr id="12" name="Rectangle 11"/>
+          <p:cNvPr id="12" name="Rounded Rectangle 11"/>
           <p:cNvSpPr/>
           <p:nvPr/>
         </p:nvSpPr>
         <p:spPr>
           <a:xfrm>
-            <a:off x="3374135" y="2322576"/>
-            <a:ext cx="2560320" cy="960120"/>
-          </a:xfrm>
-          <a:prstGeom prst="rect">
-            <a:avLst/>
+            <a:off x="3374135" y="2231136"/>
+            <a:ext cx="2560320" cy="1005840"/>
+          </a:xfrm>
+          <a:prstGeom prst="roundRect">
+            <a:avLst>
+              <a:gd name="adj" fmla="val 6000"/>
+            </a:avLst>
           </a:prstGeom>
           <a:solidFill>
             <a:srgbClr val="D5C9B4"/>
@@ -8715,17 +8801,19 @@
       </p:sp>
       <p:sp>
         <p:nvSpPr>
-          <p:cNvPr id="13" name="Rectangle 12"/>
+          <p:cNvPr id="13" name="Rounded Rectangle 12"/>
           <p:cNvSpPr/>
           <p:nvPr/>
         </p:nvSpPr>
         <p:spPr>
           <a:xfrm>
-            <a:off x="3337559" y="2286000"/>
-            <a:ext cx="2560320" cy="960120"/>
-          </a:xfrm>
-          <a:prstGeom prst="rect">
-            <a:avLst/>
+            <a:off x="3337559" y="2194560"/>
+            <a:ext cx="2560320" cy="1005840"/>
+          </a:xfrm>
+          <a:prstGeom prst="roundRect">
+            <a:avLst>
+              <a:gd name="adj" fmla="val 6000"/>
+            </a:avLst>
           </a:prstGeom>
           <a:solidFill>
             <a:srgbClr val="FFFFFF"/>
@@ -8767,7 +8855,7 @@
         </p:nvSpPr>
         <p:spPr>
           <a:xfrm>
-            <a:off x="3337559" y="2468880"/>
+            <a:off x="3337559" y="2377440"/>
             <a:ext cx="2560320" cy="365760"/>
           </a:xfrm>
           <a:prstGeom prst="rect">
@@ -8783,7 +8871,7 @@
           <a:p>
             <a:pPr algn="ctr"/>
             <a:r>
-              <a:rPr sz="1200">
+              <a:rPr sz="1550">
                 <a:solidFill>
                   <a:srgbClr val="2D4A3E"/>
                 </a:solidFill>
@@ -8803,7 +8891,7 @@
         </p:nvSpPr>
         <p:spPr>
           <a:xfrm>
-            <a:off x="5934455" y="2606040"/>
+            <a:off x="5934455" y="2542032"/>
             <a:ext cx="274320" cy="329184"/>
           </a:xfrm>
           <a:prstGeom prst="rightArrow">
@@ -8841,17 +8929,19 @@
       </p:sp>
       <p:sp>
         <p:nvSpPr>
-          <p:cNvPr id="16" name="Rectangle 15"/>
+          <p:cNvPr id="16" name="Rounded Rectangle 15"/>
           <p:cNvSpPr/>
           <p:nvPr/>
         </p:nvSpPr>
         <p:spPr>
           <a:xfrm>
-            <a:off x="6071616" y="2322576"/>
-            <a:ext cx="2560320" cy="960120"/>
-          </a:xfrm>
-          <a:prstGeom prst="rect">
-            <a:avLst/>
+            <a:off x="6071616" y="2231136"/>
+            <a:ext cx="2560320" cy="1005840"/>
+          </a:xfrm>
+          <a:prstGeom prst="roundRect">
+            <a:avLst>
+              <a:gd name="adj" fmla="val 6000"/>
+            </a:avLst>
           </a:prstGeom>
           <a:solidFill>
             <a:srgbClr val="D5C9B4"/>
@@ -8885,17 +8975,19 @@
       </p:sp>
       <p:sp>
         <p:nvSpPr>
-          <p:cNvPr id="17" name="Rectangle 16"/>
+          <p:cNvPr id="17" name="Rounded Rectangle 16"/>
           <p:cNvSpPr/>
           <p:nvPr/>
         </p:nvSpPr>
         <p:spPr>
           <a:xfrm>
-            <a:off x="6035040" y="2286000"/>
-            <a:ext cx="2560320" cy="960120"/>
-          </a:xfrm>
-          <a:prstGeom prst="rect">
-            <a:avLst/>
+            <a:off x="6035040" y="2194560"/>
+            <a:ext cx="2560320" cy="1005840"/>
+          </a:xfrm>
+          <a:prstGeom prst="roundRect">
+            <a:avLst>
+              <a:gd name="adj" fmla="val 6000"/>
+            </a:avLst>
           </a:prstGeom>
           <a:solidFill>
             <a:srgbClr val="FFFFFF"/>
@@ -8937,7 +9029,7 @@
         </p:nvSpPr>
         <p:spPr>
           <a:xfrm>
-            <a:off x="6035040" y="2468880"/>
+            <a:off x="6035040" y="2377440"/>
             <a:ext cx="2560320" cy="365760"/>
           </a:xfrm>
           <a:prstGeom prst="rect">
@@ -8953,7 +9045,7 @@
           <a:p>
             <a:pPr algn="ctr"/>
             <a:r>
-              <a:rPr sz="1200">
+              <a:rPr sz="1550">
                 <a:solidFill>
                   <a:srgbClr val="2D4A3E"/>
                 </a:solidFill>
@@ -8973,7 +9065,7 @@
         </p:nvSpPr>
         <p:spPr>
           <a:xfrm>
-            <a:off x="8631935" y="2606040"/>
+            <a:off x="8631935" y="2542032"/>
             <a:ext cx="274320" cy="329184"/>
           </a:xfrm>
           <a:prstGeom prst="rightArrow">
@@ -9011,17 +9103,19 @@
       </p:sp>
       <p:sp>
         <p:nvSpPr>
-          <p:cNvPr id="20" name="Rectangle 19"/>
+          <p:cNvPr id="20" name="Rounded Rectangle 19"/>
           <p:cNvSpPr/>
           <p:nvPr/>
         </p:nvSpPr>
         <p:spPr>
           <a:xfrm>
-            <a:off x="8769095" y="2322576"/>
-            <a:ext cx="2560320" cy="960120"/>
-          </a:xfrm>
-          <a:prstGeom prst="rect">
-            <a:avLst/>
+            <a:off x="8769095" y="2231136"/>
+            <a:ext cx="2560320" cy="1005840"/>
+          </a:xfrm>
+          <a:prstGeom prst="roundRect">
+            <a:avLst>
+              <a:gd name="adj" fmla="val 6000"/>
+            </a:avLst>
           </a:prstGeom>
           <a:solidFill>
             <a:srgbClr val="D5C9B4"/>
@@ -9055,17 +9149,19 @@
       </p:sp>
       <p:sp>
         <p:nvSpPr>
-          <p:cNvPr id="21" name="Rectangle 20"/>
+          <p:cNvPr id="21" name="Rounded Rectangle 20"/>
           <p:cNvSpPr/>
           <p:nvPr/>
         </p:nvSpPr>
         <p:spPr>
           <a:xfrm>
-            <a:off x="8732519" y="2286000"/>
-            <a:ext cx="2560320" cy="960120"/>
-          </a:xfrm>
-          <a:prstGeom prst="rect">
-            <a:avLst/>
+            <a:off x="8732519" y="2194560"/>
+            <a:ext cx="2560320" cy="1005840"/>
+          </a:xfrm>
+          <a:prstGeom prst="roundRect">
+            <a:avLst>
+              <a:gd name="adj" fmla="val 6000"/>
+            </a:avLst>
           </a:prstGeom>
           <a:solidFill>
             <a:srgbClr val="FFFFFF"/>
@@ -9107,7 +9203,7 @@
         </p:nvSpPr>
         <p:spPr>
           <a:xfrm>
-            <a:off x="8732519" y="2468880"/>
+            <a:off x="8732519" y="2377440"/>
             <a:ext cx="2560320" cy="365760"/>
           </a:xfrm>
           <a:prstGeom prst="rect">
@@ -9123,7 +9219,7 @@
           <a:p>
             <a:pPr algn="ctr"/>
             <a:r>
-              <a:rPr sz="1200">
+              <a:rPr sz="1550">
                 <a:solidFill>
                   <a:srgbClr val="2D4A3E"/>
                 </a:solidFill>
@@ -9137,17 +9233,19 @@
       </p:sp>
       <p:sp>
         <p:nvSpPr>
-          <p:cNvPr id="23" name="Rectangle 22"/>
+          <p:cNvPr id="23" name="Rounded Rectangle 22"/>
           <p:cNvSpPr/>
           <p:nvPr/>
         </p:nvSpPr>
         <p:spPr>
           <a:xfrm>
-            <a:off x="676656" y="3739896"/>
-            <a:ext cx="10881360" cy="621792"/>
-          </a:xfrm>
-          <a:prstGeom prst="rect">
-            <a:avLst/>
+            <a:off x="676656" y="3694176"/>
+            <a:ext cx="10881360" cy="640080"/>
+          </a:xfrm>
+          <a:prstGeom prst="roundRect">
+            <a:avLst>
+              <a:gd name="adj" fmla="val 6000"/>
+            </a:avLst>
           </a:prstGeom>
           <a:solidFill>
             <a:srgbClr val="D5C9B4"/>
@@ -9181,17 +9279,19 @@
       </p:sp>
       <p:sp>
         <p:nvSpPr>
-          <p:cNvPr id="24" name="Rectangle 23"/>
+          <p:cNvPr id="24" name="Rounded Rectangle 23"/>
           <p:cNvSpPr/>
           <p:nvPr/>
         </p:nvSpPr>
         <p:spPr>
           <a:xfrm>
-            <a:off x="640080" y="3703320"/>
-            <a:ext cx="10881360" cy="621792"/>
-          </a:xfrm>
-          <a:prstGeom prst="rect">
-            <a:avLst/>
+            <a:off x="640080" y="3657600"/>
+            <a:ext cx="10881360" cy="640080"/>
+          </a:xfrm>
+          <a:prstGeom prst="roundRect">
+            <a:avLst>
+              <a:gd name="adj" fmla="val 6000"/>
+            </a:avLst>
           </a:prstGeom>
           <a:solidFill>
             <a:srgbClr val="FFFFFF"/>
@@ -9227,17 +9327,19 @@
       </p:sp>
       <p:sp>
         <p:nvSpPr>
-          <p:cNvPr id="25" name="Rectangle 24"/>
+          <p:cNvPr id="25" name="Rounded Rectangle 24"/>
           <p:cNvSpPr/>
           <p:nvPr/>
         </p:nvSpPr>
         <p:spPr>
           <a:xfrm>
-            <a:off x="914400" y="3959352"/>
+            <a:off x="914400" y="3922776"/>
             <a:ext cx="109728" cy="109728"/>
           </a:xfrm>
-          <a:prstGeom prst="rect">
-            <a:avLst/>
+          <a:prstGeom prst="roundRect">
+            <a:avLst>
+              <a:gd name="adj" fmla="val 35000"/>
+            </a:avLst>
           </a:prstGeom>
           <a:solidFill>
             <a:srgbClr val="2D4A3E"/>
@@ -9277,8 +9379,8 @@
         </p:nvSpPr>
         <p:spPr>
           <a:xfrm>
-            <a:off x="1188719" y="3703320"/>
-            <a:ext cx="2743200" cy="621792"/>
+            <a:off x="1188719" y="3657600"/>
+            <a:ext cx="2743200" cy="640080"/>
           </a:xfrm>
           <a:prstGeom prst="rect">
             <a:avLst/>
@@ -9293,7 +9395,7 @@
           <a:p>
             <a:pPr algn="l"/>
             <a:r>
-              <a:rPr sz="1150">
+              <a:rPr sz="1500">
                 <a:solidFill>
                   <a:srgbClr val="2C2418"/>
                 </a:solidFill>
@@ -9313,8 +9415,8 @@
         </p:nvSpPr>
         <p:spPr>
           <a:xfrm>
-            <a:off x="4114800" y="3703320"/>
-            <a:ext cx="7223760" cy="621792"/>
+            <a:off x="4114800" y="3657600"/>
+            <a:ext cx="7223760" cy="640080"/>
           </a:xfrm>
           <a:prstGeom prst="rect">
             <a:avLst/>
@@ -9333,7 +9435,7 @@
               </a:lnSpc>
             </a:pPr>
             <a:r>
-              <a:rPr sz="1050">
+              <a:rPr sz="1400">
                 <a:solidFill>
                   <a:srgbClr val="6B6356"/>
                 </a:solidFill>
@@ -9347,17 +9449,19 @@
       </p:sp>
       <p:sp>
         <p:nvSpPr>
-          <p:cNvPr id="28" name="Rectangle 27"/>
+          <p:cNvPr id="28" name="Rounded Rectangle 27"/>
           <p:cNvSpPr/>
           <p:nvPr/>
         </p:nvSpPr>
         <p:spPr>
           <a:xfrm>
-            <a:off x="676656" y="4453128"/>
-            <a:ext cx="10881360" cy="621792"/>
-          </a:xfrm>
-          <a:prstGeom prst="rect">
-            <a:avLst/>
+            <a:off x="676656" y="4425696"/>
+            <a:ext cx="10881360" cy="640080"/>
+          </a:xfrm>
+          <a:prstGeom prst="roundRect">
+            <a:avLst>
+              <a:gd name="adj" fmla="val 6000"/>
+            </a:avLst>
           </a:prstGeom>
           <a:solidFill>
             <a:srgbClr val="D5C9B4"/>
@@ -9391,17 +9495,19 @@
       </p:sp>
       <p:sp>
         <p:nvSpPr>
-          <p:cNvPr id="29" name="Rectangle 28"/>
+          <p:cNvPr id="29" name="Rounded Rectangle 28"/>
           <p:cNvSpPr/>
           <p:nvPr/>
         </p:nvSpPr>
         <p:spPr>
           <a:xfrm>
-            <a:off x="640080" y="4416552"/>
-            <a:ext cx="10881360" cy="621792"/>
-          </a:xfrm>
-          <a:prstGeom prst="rect">
-            <a:avLst/>
+            <a:off x="640080" y="4389120"/>
+            <a:ext cx="10881360" cy="640080"/>
+          </a:xfrm>
+          <a:prstGeom prst="roundRect">
+            <a:avLst>
+              <a:gd name="adj" fmla="val 6000"/>
+            </a:avLst>
           </a:prstGeom>
           <a:solidFill>
             <a:srgbClr val="FFFFFF"/>
@@ -9437,17 +9543,19 @@
       </p:sp>
       <p:sp>
         <p:nvSpPr>
-          <p:cNvPr id="30" name="Rectangle 29"/>
+          <p:cNvPr id="30" name="Rounded Rectangle 29"/>
           <p:cNvSpPr/>
           <p:nvPr/>
         </p:nvSpPr>
         <p:spPr>
           <a:xfrm>
-            <a:off x="914400" y="4672584"/>
+            <a:off x="914400" y="4654296"/>
             <a:ext cx="109728" cy="109728"/>
           </a:xfrm>
-          <a:prstGeom prst="rect">
-            <a:avLst/>
+          <a:prstGeom prst="roundRect">
+            <a:avLst>
+              <a:gd name="adj" fmla="val 35000"/>
+            </a:avLst>
           </a:prstGeom>
           <a:solidFill>
             <a:srgbClr val="2D4A3E"/>
@@ -9487,8 +9595,8 @@
         </p:nvSpPr>
         <p:spPr>
           <a:xfrm>
-            <a:off x="1188719" y="4416552"/>
-            <a:ext cx="2743200" cy="621792"/>
+            <a:off x="1188719" y="4389120"/>
+            <a:ext cx="2743200" cy="640080"/>
           </a:xfrm>
           <a:prstGeom prst="rect">
             <a:avLst/>
@@ -9503,7 +9611,7 @@
           <a:p>
             <a:pPr algn="l"/>
             <a:r>
-              <a:rPr sz="1150">
+              <a:rPr sz="1500">
                 <a:solidFill>
                   <a:srgbClr val="2C2418"/>
                 </a:solidFill>
@@ -9523,8 +9631,8 @@
         </p:nvSpPr>
         <p:spPr>
           <a:xfrm>
-            <a:off x="4114800" y="4416552"/>
-            <a:ext cx="7223760" cy="621792"/>
+            <a:off x="4114800" y="4389120"/>
+            <a:ext cx="7223760" cy="640080"/>
           </a:xfrm>
           <a:prstGeom prst="rect">
             <a:avLst/>
@@ -9543,7 +9651,7 @@
               </a:lnSpc>
             </a:pPr>
             <a:r>
-              <a:rPr sz="1050">
+              <a:rPr sz="1400">
                 <a:solidFill>
                   <a:srgbClr val="6B6356"/>
                 </a:solidFill>
@@ -9557,17 +9665,19 @@
       </p:sp>
       <p:sp>
         <p:nvSpPr>
-          <p:cNvPr id="33" name="Rectangle 32"/>
+          <p:cNvPr id="33" name="Rounded Rectangle 32"/>
           <p:cNvSpPr/>
           <p:nvPr/>
         </p:nvSpPr>
         <p:spPr>
           <a:xfrm>
-            <a:off x="676656" y="5166359"/>
-            <a:ext cx="10881360" cy="621792"/>
-          </a:xfrm>
-          <a:prstGeom prst="rect">
-            <a:avLst/>
+            <a:off x="676656" y="5157216"/>
+            <a:ext cx="10881360" cy="640080"/>
+          </a:xfrm>
+          <a:prstGeom prst="roundRect">
+            <a:avLst>
+              <a:gd name="adj" fmla="val 6000"/>
+            </a:avLst>
           </a:prstGeom>
           <a:solidFill>
             <a:srgbClr val="D5C9B4"/>
@@ -9601,17 +9711,19 @@
       </p:sp>
       <p:sp>
         <p:nvSpPr>
-          <p:cNvPr id="34" name="Rectangle 33"/>
+          <p:cNvPr id="34" name="Rounded Rectangle 33"/>
           <p:cNvSpPr/>
           <p:nvPr/>
         </p:nvSpPr>
         <p:spPr>
           <a:xfrm>
-            <a:off x="640080" y="5129783"/>
-            <a:ext cx="10881360" cy="621792"/>
-          </a:xfrm>
-          <a:prstGeom prst="rect">
-            <a:avLst/>
+            <a:off x="640080" y="5120640"/>
+            <a:ext cx="10881360" cy="640080"/>
+          </a:xfrm>
+          <a:prstGeom prst="roundRect">
+            <a:avLst>
+              <a:gd name="adj" fmla="val 6000"/>
+            </a:avLst>
           </a:prstGeom>
           <a:solidFill>
             <a:srgbClr val="FFFFFF"/>
@@ -9647,7 +9759,7 @@
       </p:sp>
       <p:sp>
         <p:nvSpPr>
-          <p:cNvPr id="35" name="Rectangle 34"/>
+          <p:cNvPr id="35" name="Rounded Rectangle 34"/>
           <p:cNvSpPr/>
           <p:nvPr/>
         </p:nvSpPr>
@@ -9656,8 +9768,10 @@
             <a:off x="914400" y="5385816"/>
             <a:ext cx="109728" cy="109728"/>
           </a:xfrm>
-          <a:prstGeom prst="rect">
-            <a:avLst/>
+          <a:prstGeom prst="roundRect">
+            <a:avLst>
+              <a:gd name="adj" fmla="val 35000"/>
+            </a:avLst>
           </a:prstGeom>
           <a:solidFill>
             <a:srgbClr val="2D4A3E"/>
@@ -9697,8 +9811,8 @@
         </p:nvSpPr>
         <p:spPr>
           <a:xfrm>
-            <a:off x="1188719" y="5129783"/>
-            <a:ext cx="2743200" cy="621792"/>
+            <a:off x="1188719" y="5120640"/>
+            <a:ext cx="2743200" cy="640080"/>
           </a:xfrm>
           <a:prstGeom prst="rect">
             <a:avLst/>
@@ -9713,7 +9827,7 @@
           <a:p>
             <a:pPr algn="l"/>
             <a:r>
-              <a:rPr sz="1150">
+              <a:rPr sz="1500">
                 <a:solidFill>
                   <a:srgbClr val="2C2418"/>
                 </a:solidFill>
@@ -9733,8 +9847,8 @@
         </p:nvSpPr>
         <p:spPr>
           <a:xfrm>
-            <a:off x="4114800" y="5129783"/>
-            <a:ext cx="7223760" cy="621792"/>
+            <a:off x="4114800" y="5120640"/>
+            <a:ext cx="7223760" cy="640080"/>
           </a:xfrm>
           <a:prstGeom prst="rect">
             <a:avLst/>
@@ -9753,7 +9867,7 @@
               </a:lnSpc>
             </a:pPr>
             <a:r>
-              <a:rPr sz="1050">
+              <a:rPr sz="1400">
                 <a:solidFill>
                   <a:srgbClr val="6B6356"/>
                 </a:solidFill>
@@ -9767,17 +9881,19 @@
       </p:sp>
       <p:sp>
         <p:nvSpPr>
-          <p:cNvPr id="38" name="Rectangle 37"/>
+          <p:cNvPr id="38" name="Rounded Rectangle 37"/>
           <p:cNvSpPr/>
           <p:nvPr/>
         </p:nvSpPr>
         <p:spPr>
           <a:xfrm>
-            <a:off x="676656" y="5879592"/>
-            <a:ext cx="10881360" cy="621792"/>
-          </a:xfrm>
-          <a:prstGeom prst="rect">
-            <a:avLst/>
+            <a:off x="676656" y="5888736"/>
+            <a:ext cx="10881360" cy="640080"/>
+          </a:xfrm>
+          <a:prstGeom prst="roundRect">
+            <a:avLst>
+              <a:gd name="adj" fmla="val 6000"/>
+            </a:avLst>
           </a:prstGeom>
           <a:solidFill>
             <a:srgbClr val="D5C9B4"/>
@@ -9811,17 +9927,19 @@
       </p:sp>
       <p:sp>
         <p:nvSpPr>
-          <p:cNvPr id="39" name="Rectangle 38"/>
+          <p:cNvPr id="39" name="Rounded Rectangle 38"/>
           <p:cNvSpPr/>
           <p:nvPr/>
         </p:nvSpPr>
         <p:spPr>
           <a:xfrm>
-            <a:off x="640080" y="5843016"/>
-            <a:ext cx="10881360" cy="621792"/>
-          </a:xfrm>
-          <a:prstGeom prst="rect">
-            <a:avLst/>
+            <a:off x="640080" y="5852160"/>
+            <a:ext cx="10881360" cy="640080"/>
+          </a:xfrm>
+          <a:prstGeom prst="roundRect">
+            <a:avLst>
+              <a:gd name="adj" fmla="val 6000"/>
+            </a:avLst>
           </a:prstGeom>
           <a:solidFill>
             <a:srgbClr val="FFFFFF"/>
@@ -9857,17 +9975,19 @@
       </p:sp>
       <p:sp>
         <p:nvSpPr>
-          <p:cNvPr id="40" name="Rectangle 39"/>
+          <p:cNvPr id="40" name="Rounded Rectangle 39"/>
           <p:cNvSpPr/>
           <p:nvPr/>
         </p:nvSpPr>
         <p:spPr>
           <a:xfrm>
-            <a:off x="914400" y="6099048"/>
+            <a:off x="914400" y="6117336"/>
             <a:ext cx="109728" cy="109728"/>
           </a:xfrm>
-          <a:prstGeom prst="rect">
-            <a:avLst/>
+          <a:prstGeom prst="roundRect">
+            <a:avLst>
+              <a:gd name="adj" fmla="val 35000"/>
+            </a:avLst>
           </a:prstGeom>
           <a:solidFill>
             <a:srgbClr val="2D4A3E"/>
@@ -9907,8 +10027,8 @@
         </p:nvSpPr>
         <p:spPr>
           <a:xfrm>
-            <a:off x="1188719" y="5843016"/>
-            <a:ext cx="2743200" cy="621792"/>
+            <a:off x="1188719" y="5852160"/>
+            <a:ext cx="2743200" cy="640080"/>
           </a:xfrm>
           <a:prstGeom prst="rect">
             <a:avLst/>
@@ -9923,7 +10043,7 @@
           <a:p>
             <a:pPr algn="l"/>
             <a:r>
-              <a:rPr sz="1150">
+              <a:rPr sz="1500">
                 <a:solidFill>
                   <a:srgbClr val="2C2418"/>
                 </a:solidFill>
@@ -9943,8 +10063,8 @@
         </p:nvSpPr>
         <p:spPr>
           <a:xfrm>
-            <a:off x="4114800" y="5843016"/>
-            <a:ext cx="7223760" cy="621792"/>
+            <a:off x="4114800" y="5852160"/>
+            <a:ext cx="7223760" cy="640080"/>
           </a:xfrm>
           <a:prstGeom prst="rect">
             <a:avLst/>
@@ -9963,7 +10083,7 @@
               </a:lnSpc>
             </a:pPr>
             <a:r>
-              <a:rPr sz="1050">
+              <a:rPr sz="1400">
                 <a:solidFill>
                   <a:srgbClr val="6B6356"/>
                 </a:solidFill>
@@ -10117,7 +10237,7 @@
         </p:nvSpPr>
         <p:spPr>
           <a:xfrm>
-            <a:off x="640080" y="1600200"/>
+            <a:off x="640080" y="1481328"/>
             <a:ext cx="10881360" cy="13716"/>
           </a:xfrm>
           <a:prstGeom prst="rect">
@@ -10177,7 +10297,7 @@
           <a:p>
             <a:pPr algn="r"/>
             <a:r>
-              <a:rPr sz="900">
+              <a:rPr sz="1150">
                 <a:solidFill>
                   <a:srgbClr val="9B9182"/>
                 </a:solidFill>
@@ -10191,17 +10311,19 @@
       </p:sp>
       <p:sp>
         <p:nvSpPr>
-          <p:cNvPr id="7" name="Rectangle 6"/>
+          <p:cNvPr id="7" name="Rounded Rectangle 6"/>
           <p:cNvSpPr/>
           <p:nvPr/>
         </p:nvSpPr>
         <p:spPr>
           <a:xfrm>
-            <a:off x="676656" y="2048256"/>
-            <a:ext cx="10881360" cy="713232"/>
-          </a:xfrm>
-          <a:prstGeom prst="rect">
-            <a:avLst/>
+            <a:off x="676656" y="1911095"/>
+            <a:ext cx="10881360" cy="731520"/>
+          </a:xfrm>
+          <a:prstGeom prst="roundRect">
+            <a:avLst>
+              <a:gd name="adj" fmla="val 6000"/>
+            </a:avLst>
           </a:prstGeom>
           <a:solidFill>
             <a:srgbClr val="D5C9B4"/>
@@ -10235,17 +10357,19 @@
       </p:sp>
       <p:sp>
         <p:nvSpPr>
-          <p:cNvPr id="8" name="Rectangle 7"/>
+          <p:cNvPr id="8" name="Rounded Rectangle 7"/>
           <p:cNvSpPr/>
           <p:nvPr/>
         </p:nvSpPr>
         <p:spPr>
           <a:xfrm>
-            <a:off x="640080" y="2011680"/>
-            <a:ext cx="10881360" cy="713232"/>
-          </a:xfrm>
-          <a:prstGeom prst="rect">
-            <a:avLst/>
+            <a:off x="640080" y="1874519"/>
+            <a:ext cx="10881360" cy="731520"/>
+          </a:xfrm>
+          <a:prstGeom prst="roundRect">
+            <a:avLst>
+              <a:gd name="adj" fmla="val 6000"/>
+            </a:avLst>
           </a:prstGeom>
           <a:solidFill>
             <a:srgbClr val="FFFFFF"/>
@@ -10281,17 +10405,19 @@
       </p:sp>
       <p:sp>
         <p:nvSpPr>
-          <p:cNvPr id="9" name="Rectangle 8"/>
+          <p:cNvPr id="9" name="Rounded Rectangle 8"/>
           <p:cNvSpPr/>
           <p:nvPr/>
         </p:nvSpPr>
         <p:spPr>
           <a:xfrm>
-            <a:off x="914400" y="2313432"/>
+            <a:off x="914400" y="2185415"/>
             <a:ext cx="109728" cy="109728"/>
           </a:xfrm>
-          <a:prstGeom prst="rect">
-            <a:avLst/>
+          <a:prstGeom prst="roundRect">
+            <a:avLst>
+              <a:gd name="adj" fmla="val 35000"/>
+            </a:avLst>
           </a:prstGeom>
           <a:solidFill>
             <a:srgbClr val="2D4A3E"/>
@@ -10331,8 +10457,8 @@
         </p:nvSpPr>
         <p:spPr>
           <a:xfrm>
-            <a:off x="1188719" y="2011680"/>
-            <a:ext cx="2743200" cy="713232"/>
+            <a:off x="1188719" y="1874519"/>
+            <a:ext cx="2743200" cy="731520"/>
           </a:xfrm>
           <a:prstGeom prst="rect">
             <a:avLst/>
@@ -10347,7 +10473,7 @@
           <a:p>
             <a:pPr algn="l"/>
             <a:r>
-              <a:rPr sz="1150">
+              <a:rPr sz="1500">
                 <a:solidFill>
                   <a:srgbClr val="2C2418"/>
                 </a:solidFill>
@@ -10367,8 +10493,8 @@
         </p:nvSpPr>
         <p:spPr>
           <a:xfrm>
-            <a:off x="4114800" y="2011680"/>
-            <a:ext cx="7223760" cy="713232"/>
+            <a:off x="4114800" y="1874519"/>
+            <a:ext cx="7223760" cy="731520"/>
           </a:xfrm>
           <a:prstGeom prst="rect">
             <a:avLst/>
@@ -10387,31 +10513,33 @@
               </a:lnSpc>
             </a:pPr>
             <a:r>
-              <a:rPr sz="1050">
+              <a:rPr sz="1400">
                 <a:solidFill>
                   <a:srgbClr val="6B6356"/>
                 </a:solidFill>
                 <a:latin typeface="맑은 고딕"/>
                 <a:ea typeface="맑은 고딕"/>
               </a:rPr>
-              <a:t>자막 + 시스템 프롬프트 + JSON Schema → strict mode → Supabase jsonb 저장</a:t>
-            </a:r>
-          </a:p>
-        </p:txBody>
-      </p:sp>
-      <p:sp>
-        <p:nvSpPr>
-          <p:cNvPr id="12" name="Rectangle 11"/>
+              <a:t>자막 + 시스템 프롬프트 + JSON Schema → strict mode → Supabase jsonb</a:t>
+            </a:r>
+          </a:p>
+        </p:txBody>
+      </p:sp>
+      <p:sp>
+        <p:nvSpPr>
+          <p:cNvPr id="12" name="Rounded Rectangle 11"/>
           <p:cNvSpPr/>
           <p:nvPr/>
         </p:nvSpPr>
         <p:spPr>
           <a:xfrm>
-            <a:off x="676656" y="2871216"/>
-            <a:ext cx="10881360" cy="713232"/>
-          </a:xfrm>
-          <a:prstGeom prst="rect">
-            <a:avLst/>
+            <a:off x="676656" y="2752344"/>
+            <a:ext cx="10881360" cy="731520"/>
+          </a:xfrm>
+          <a:prstGeom prst="roundRect">
+            <a:avLst>
+              <a:gd name="adj" fmla="val 6000"/>
+            </a:avLst>
           </a:prstGeom>
           <a:solidFill>
             <a:srgbClr val="D5C9B4"/>
@@ -10445,17 +10573,19 @@
       </p:sp>
       <p:sp>
         <p:nvSpPr>
-          <p:cNvPr id="13" name="Rectangle 12"/>
+          <p:cNvPr id="13" name="Rounded Rectangle 12"/>
           <p:cNvSpPr/>
           <p:nvPr/>
         </p:nvSpPr>
         <p:spPr>
           <a:xfrm>
-            <a:off x="640080" y="2834640"/>
-            <a:ext cx="10881360" cy="713232"/>
-          </a:xfrm>
-          <a:prstGeom prst="rect">
-            <a:avLst/>
+            <a:off x="640080" y="2715768"/>
+            <a:ext cx="10881360" cy="731520"/>
+          </a:xfrm>
+          <a:prstGeom prst="roundRect">
+            <a:avLst>
+              <a:gd name="adj" fmla="val 6000"/>
+            </a:avLst>
           </a:prstGeom>
           <a:solidFill>
             <a:srgbClr val="FFFFFF"/>
@@ -10491,17 +10621,19 @@
       </p:sp>
       <p:sp>
         <p:nvSpPr>
-          <p:cNvPr id="14" name="Rectangle 13"/>
+          <p:cNvPr id="14" name="Rounded Rectangle 13"/>
           <p:cNvSpPr/>
           <p:nvPr/>
         </p:nvSpPr>
         <p:spPr>
           <a:xfrm>
-            <a:off x="914400" y="3136392"/>
+            <a:off x="914400" y="3026663"/>
             <a:ext cx="109728" cy="109728"/>
           </a:xfrm>
-          <a:prstGeom prst="rect">
-            <a:avLst/>
+          <a:prstGeom prst="roundRect">
+            <a:avLst>
+              <a:gd name="adj" fmla="val 35000"/>
+            </a:avLst>
           </a:prstGeom>
           <a:solidFill>
             <a:srgbClr val="2D4A3E"/>
@@ -10541,8 +10673,8 @@
         </p:nvSpPr>
         <p:spPr>
           <a:xfrm>
-            <a:off x="1188719" y="2834640"/>
-            <a:ext cx="2743200" cy="713232"/>
+            <a:off x="1188719" y="2715768"/>
+            <a:ext cx="2743200" cy="731520"/>
           </a:xfrm>
           <a:prstGeom prst="rect">
             <a:avLst/>
@@ -10557,7 +10689,7 @@
           <a:p>
             <a:pPr algn="l"/>
             <a:r>
-              <a:rPr sz="1150">
+              <a:rPr sz="1500">
                 <a:solidFill>
                   <a:srgbClr val="2C2418"/>
                 </a:solidFill>
@@ -10577,8 +10709,8 @@
         </p:nvSpPr>
         <p:spPr>
           <a:xfrm>
-            <a:off x="4114800" y="2834640"/>
-            <a:ext cx="7223760" cy="713232"/>
+            <a:off x="4114800" y="2715768"/>
+            <a:ext cx="7223760" cy="731520"/>
           </a:xfrm>
           <a:prstGeom prst="rect">
             <a:avLst/>
@@ -10597,7 +10729,7 @@
               </a:lnSpc>
             </a:pPr>
             <a:r>
-              <a:rPr sz="1050">
+              <a:rPr sz="1400">
                 <a:solidFill>
                   <a:srgbClr val="6B6356"/>
                 </a:solidFill>
@@ -10611,17 +10743,19 @@
       </p:sp>
       <p:sp>
         <p:nvSpPr>
-          <p:cNvPr id="17" name="Rectangle 16"/>
+          <p:cNvPr id="17" name="Rounded Rectangle 16"/>
           <p:cNvSpPr/>
           <p:nvPr/>
         </p:nvSpPr>
         <p:spPr>
           <a:xfrm>
-            <a:off x="676656" y="3694176"/>
-            <a:ext cx="10881360" cy="713232"/>
-          </a:xfrm>
-          <a:prstGeom prst="rect">
-            <a:avLst/>
+            <a:off x="676656" y="3593591"/>
+            <a:ext cx="10881360" cy="731520"/>
+          </a:xfrm>
+          <a:prstGeom prst="roundRect">
+            <a:avLst>
+              <a:gd name="adj" fmla="val 6000"/>
+            </a:avLst>
           </a:prstGeom>
           <a:solidFill>
             <a:srgbClr val="D5C9B4"/>
@@ -10655,17 +10789,19 @@
       </p:sp>
       <p:sp>
         <p:nvSpPr>
-          <p:cNvPr id="18" name="Rectangle 17"/>
+          <p:cNvPr id="18" name="Rounded Rectangle 17"/>
           <p:cNvSpPr/>
           <p:nvPr/>
         </p:nvSpPr>
         <p:spPr>
           <a:xfrm>
-            <a:off x="640080" y="3657600"/>
-            <a:ext cx="10881360" cy="713232"/>
-          </a:xfrm>
-          <a:prstGeom prst="rect">
-            <a:avLst/>
+            <a:off x="640080" y="3557015"/>
+            <a:ext cx="10881360" cy="731520"/>
+          </a:xfrm>
+          <a:prstGeom prst="roundRect">
+            <a:avLst>
+              <a:gd name="adj" fmla="val 6000"/>
+            </a:avLst>
           </a:prstGeom>
           <a:solidFill>
             <a:srgbClr val="FFFFFF"/>
@@ -10701,17 +10837,19 @@
       </p:sp>
       <p:sp>
         <p:nvSpPr>
-          <p:cNvPr id="19" name="Rectangle 18"/>
+          <p:cNvPr id="19" name="Rounded Rectangle 18"/>
           <p:cNvSpPr/>
           <p:nvPr/>
         </p:nvSpPr>
         <p:spPr>
           <a:xfrm>
-            <a:off x="914400" y="3959352"/>
+            <a:off x="914400" y="3867912"/>
             <a:ext cx="109728" cy="109728"/>
           </a:xfrm>
-          <a:prstGeom prst="rect">
-            <a:avLst/>
+          <a:prstGeom prst="roundRect">
+            <a:avLst>
+              <a:gd name="adj" fmla="val 35000"/>
+            </a:avLst>
           </a:prstGeom>
           <a:solidFill>
             <a:srgbClr val="2D4A3E"/>
@@ -10751,8 +10889,8 @@
         </p:nvSpPr>
         <p:spPr>
           <a:xfrm>
-            <a:off x="1188719" y="3657600"/>
-            <a:ext cx="2743200" cy="713232"/>
+            <a:off x="1188719" y="3557015"/>
+            <a:ext cx="2743200" cy="731520"/>
           </a:xfrm>
           <a:prstGeom prst="rect">
             <a:avLst/>
@@ -10767,7 +10905,7 @@
           <a:p>
             <a:pPr algn="l"/>
             <a:r>
-              <a:rPr sz="1150">
+              <a:rPr sz="1500">
                 <a:solidFill>
                   <a:srgbClr val="2C2418"/>
                 </a:solidFill>
@@ -10787,8 +10925,8 @@
         </p:nvSpPr>
         <p:spPr>
           <a:xfrm>
-            <a:off x="4114800" y="3657600"/>
-            <a:ext cx="7223760" cy="713232"/>
+            <a:off x="4114800" y="3557015"/>
+            <a:ext cx="7223760" cy="731520"/>
           </a:xfrm>
           <a:prstGeom prst="rect">
             <a:avLst/>
@@ -10807,31 +10945,33 @@
               </a:lnSpc>
             </a:pPr>
             <a:r>
-              <a:rPr sz="1050">
+              <a:rPr sz="1400">
                 <a:solidFill>
                   <a:srgbClr val="6B6356"/>
                 </a:solidFill>
                 <a:latin typeface="맑은 고딕"/>
                 <a:ea typeface="맑은 고딕"/>
               </a:rPr>
-              <a:t>feeds/videos.xml?channel_id 폴링 → XML 파싱 → 키워드 매치 → DB INSERT</a:t>
-            </a:r>
-          </a:p>
-        </p:txBody>
-      </p:sp>
-      <p:sp>
-        <p:nvSpPr>
-          <p:cNvPr id="22" name="Rectangle 21"/>
+              <a:t>feeds/videos.xml?channel_id 폴링 → XML 파싱 → 키워드 매치 → INSERT</a:t>
+            </a:r>
+          </a:p>
+        </p:txBody>
+      </p:sp>
+      <p:sp>
+        <p:nvSpPr>
+          <p:cNvPr id="22" name="Rounded Rectangle 21"/>
           <p:cNvSpPr/>
           <p:nvPr/>
         </p:nvSpPr>
         <p:spPr>
           <a:xfrm>
-            <a:off x="676656" y="4517136"/>
-            <a:ext cx="10881360" cy="713232"/>
-          </a:xfrm>
-          <a:prstGeom prst="rect">
-            <a:avLst/>
+            <a:off x="676656" y="4434840"/>
+            <a:ext cx="10881360" cy="731520"/>
+          </a:xfrm>
+          <a:prstGeom prst="roundRect">
+            <a:avLst>
+              <a:gd name="adj" fmla="val 6000"/>
+            </a:avLst>
           </a:prstGeom>
           <a:solidFill>
             <a:srgbClr val="D5C9B4"/>
@@ -10865,17 +11005,19 @@
       </p:sp>
       <p:sp>
         <p:nvSpPr>
-          <p:cNvPr id="23" name="Rectangle 22"/>
+          <p:cNvPr id="23" name="Rounded Rectangle 22"/>
           <p:cNvSpPr/>
           <p:nvPr/>
         </p:nvSpPr>
         <p:spPr>
           <a:xfrm>
-            <a:off x="640080" y="4480560"/>
-            <a:ext cx="10881360" cy="713232"/>
-          </a:xfrm>
-          <a:prstGeom prst="rect">
-            <a:avLst/>
+            <a:off x="640080" y="4398264"/>
+            <a:ext cx="10881360" cy="731520"/>
+          </a:xfrm>
+          <a:prstGeom prst="roundRect">
+            <a:avLst>
+              <a:gd name="adj" fmla="val 6000"/>
+            </a:avLst>
           </a:prstGeom>
           <a:solidFill>
             <a:srgbClr val="FFFFFF"/>
@@ -10911,17 +11053,19 @@
       </p:sp>
       <p:sp>
         <p:nvSpPr>
-          <p:cNvPr id="24" name="Rectangle 23"/>
+          <p:cNvPr id="24" name="Rounded Rectangle 23"/>
           <p:cNvSpPr/>
           <p:nvPr/>
         </p:nvSpPr>
         <p:spPr>
           <a:xfrm>
-            <a:off x="914400" y="4782312"/>
+            <a:off x="914400" y="4709160"/>
             <a:ext cx="109728" cy="109728"/>
           </a:xfrm>
-          <a:prstGeom prst="rect">
-            <a:avLst/>
+          <a:prstGeom prst="roundRect">
+            <a:avLst>
+              <a:gd name="adj" fmla="val 35000"/>
+            </a:avLst>
           </a:prstGeom>
           <a:solidFill>
             <a:srgbClr val="2D4A3E"/>
@@ -10961,8 +11105,8 @@
         </p:nvSpPr>
         <p:spPr>
           <a:xfrm>
-            <a:off x="1188719" y="4480560"/>
-            <a:ext cx="2743200" cy="713232"/>
+            <a:off x="1188719" y="4398264"/>
+            <a:ext cx="2743200" cy="731520"/>
           </a:xfrm>
           <a:prstGeom prst="rect">
             <a:avLst/>
@@ -10977,7 +11121,7 @@
           <a:p>
             <a:pPr algn="l"/>
             <a:r>
-              <a:rPr sz="1150">
+              <a:rPr sz="1500">
                 <a:solidFill>
                   <a:srgbClr val="2C2418"/>
                 </a:solidFill>
@@ -10997,8 +11141,8 @@
         </p:nvSpPr>
         <p:spPr>
           <a:xfrm>
-            <a:off x="4114800" y="4480560"/>
-            <a:ext cx="7223760" cy="713232"/>
+            <a:off x="4114800" y="4398264"/>
+            <a:ext cx="7223760" cy="731520"/>
           </a:xfrm>
           <a:prstGeom prst="rect">
             <a:avLst/>
@@ -11017,7 +11161,7 @@
               </a:lnSpc>
             </a:pPr>
             <a:r>
-              <a:rPr sz="1050">
+              <a:rPr sz="1400">
                 <a:solidFill>
                   <a:srgbClr val="6B6356"/>
                 </a:solidFill>
@@ -11031,17 +11175,19 @@
       </p:sp>
       <p:sp>
         <p:nvSpPr>
-          <p:cNvPr id="27" name="Rectangle 26"/>
+          <p:cNvPr id="27" name="Rounded Rectangle 26"/>
           <p:cNvSpPr/>
           <p:nvPr/>
         </p:nvSpPr>
         <p:spPr>
           <a:xfrm>
-            <a:off x="676656" y="5340096"/>
-            <a:ext cx="10881360" cy="713232"/>
-          </a:xfrm>
-          <a:prstGeom prst="rect">
-            <a:avLst/>
+            <a:off x="676656" y="5276088"/>
+            <a:ext cx="10881360" cy="731520"/>
+          </a:xfrm>
+          <a:prstGeom prst="roundRect">
+            <a:avLst>
+              <a:gd name="adj" fmla="val 6000"/>
+            </a:avLst>
           </a:prstGeom>
           <a:solidFill>
             <a:srgbClr val="D5C9B4"/>
@@ -11075,17 +11221,19 @@
       </p:sp>
       <p:sp>
         <p:nvSpPr>
-          <p:cNvPr id="28" name="Rectangle 27"/>
+          <p:cNvPr id="28" name="Rounded Rectangle 27"/>
           <p:cNvSpPr/>
           <p:nvPr/>
         </p:nvSpPr>
         <p:spPr>
           <a:xfrm>
-            <a:off x="640080" y="5303520"/>
-            <a:ext cx="10881360" cy="713232"/>
-          </a:xfrm>
-          <a:prstGeom prst="rect">
-            <a:avLst/>
+            <a:off x="640080" y="5239512"/>
+            <a:ext cx="10881360" cy="731520"/>
+          </a:xfrm>
+          <a:prstGeom prst="roundRect">
+            <a:avLst>
+              <a:gd name="adj" fmla="val 6000"/>
+            </a:avLst>
           </a:prstGeom>
           <a:solidFill>
             <a:srgbClr val="FFFFFF"/>
@@ -11121,17 +11269,19 @@
       </p:sp>
       <p:sp>
         <p:nvSpPr>
-          <p:cNvPr id="29" name="Rectangle 28"/>
+          <p:cNvPr id="29" name="Rounded Rectangle 28"/>
           <p:cNvSpPr/>
           <p:nvPr/>
         </p:nvSpPr>
         <p:spPr>
           <a:xfrm>
-            <a:off x="914400" y="5605272"/>
+            <a:off x="914400" y="5550408"/>
             <a:ext cx="109728" cy="109728"/>
           </a:xfrm>
-          <a:prstGeom prst="rect">
-            <a:avLst/>
+          <a:prstGeom prst="roundRect">
+            <a:avLst>
+              <a:gd name="adj" fmla="val 35000"/>
+            </a:avLst>
           </a:prstGeom>
           <a:solidFill>
             <a:srgbClr val="2D4A3E"/>
@@ -11171,8 +11321,8 @@
         </p:nvSpPr>
         <p:spPr>
           <a:xfrm>
-            <a:off x="1188719" y="5303520"/>
-            <a:ext cx="2743200" cy="713232"/>
+            <a:off x="1188719" y="5239512"/>
+            <a:ext cx="2743200" cy="731520"/>
           </a:xfrm>
           <a:prstGeom prst="rect">
             <a:avLst/>
@@ -11187,7 +11337,7 @@
           <a:p>
             <a:pPr algn="l"/>
             <a:r>
-              <a:rPr sz="1150">
+              <a:rPr sz="1500">
                 <a:solidFill>
                   <a:srgbClr val="2C2418"/>
                 </a:solidFill>
@@ -11207,8 +11357,8 @@
         </p:nvSpPr>
         <p:spPr>
           <a:xfrm>
-            <a:off x="4114800" y="5303520"/>
-            <a:ext cx="7223760" cy="713232"/>
+            <a:off x="4114800" y="5239512"/>
+            <a:ext cx="7223760" cy="731520"/>
           </a:xfrm>
           <a:prstGeom prst="rect">
             <a:avLst/>
@@ -11227,14 +11377,14 @@
               </a:lnSpc>
             </a:pPr>
             <a:r>
-              <a:rPr sz="1050">
+              <a:rPr sz="1400">
                 <a:solidFill>
                   <a:srgbClr val="6B6356"/>
                 </a:solidFill>
                 <a:latin typeface="맑은 고딕"/>
                 <a:ea typeface="맑은 고딕"/>
               </a:rPr>
-              <a:t>vercel.json crons → 매일 0시 /api/cron. push 시 GitHub webhook 자동 재배포</a:t>
+              <a:t>vercel.json crons → 매일 0시 /api/cron. push 시 자동 재배포</a:t>
             </a:r>
           </a:p>
         </p:txBody>
@@ -11247,7 +11397,7 @@
         </p:nvSpPr>
         <p:spPr>
           <a:xfrm>
-            <a:off x="640080" y="6355080"/>
+            <a:off x="640080" y="6309360"/>
             <a:ext cx="10881360" cy="320040"/>
           </a:xfrm>
           <a:prstGeom prst="rect">
@@ -11263,7 +11413,7 @@
           <a:p>
             <a:pPr algn="l"/>
             <a:r>
-              <a:rPr sz="950">
+              <a:rPr sz="1250">
                 <a:solidFill>
                   <a:srgbClr val="9B9182"/>
                 </a:solidFill>
@@ -11417,7 +11567,7 @@
         </p:nvSpPr>
         <p:spPr>
           <a:xfrm>
-            <a:off x="640080" y="1600200"/>
+            <a:off x="640080" y="1481328"/>
             <a:ext cx="10881360" cy="13716"/>
           </a:xfrm>
           <a:prstGeom prst="rect">
@@ -11477,7 +11627,7 @@
           <a:p>
             <a:pPr algn="r"/>
             <a:r>
-              <a:rPr sz="900">
+              <a:rPr sz="1150">
                 <a:solidFill>
                   <a:srgbClr val="9B9182"/>
                 </a:solidFill>
@@ -11491,17 +11641,19 @@
       </p:sp>
       <p:sp>
         <p:nvSpPr>
-          <p:cNvPr id="7" name="Rectangle 6"/>
+          <p:cNvPr id="7" name="Rounded Rectangle 6"/>
           <p:cNvSpPr/>
           <p:nvPr/>
         </p:nvSpPr>
         <p:spPr>
           <a:xfrm>
-            <a:off x="676656" y="2048256"/>
-            <a:ext cx="10881360" cy="713232"/>
-          </a:xfrm>
-          <a:prstGeom prst="rect">
-            <a:avLst/>
+            <a:off x="676656" y="1911095"/>
+            <a:ext cx="10881360" cy="731520"/>
+          </a:xfrm>
+          <a:prstGeom prst="roundRect">
+            <a:avLst>
+              <a:gd name="adj" fmla="val 6000"/>
+            </a:avLst>
           </a:prstGeom>
           <a:solidFill>
             <a:srgbClr val="D5C9B4"/>
@@ -11535,17 +11687,19 @@
       </p:sp>
       <p:sp>
         <p:nvSpPr>
-          <p:cNvPr id="8" name="Rectangle 7"/>
+          <p:cNvPr id="8" name="Rounded Rectangle 7"/>
           <p:cNvSpPr/>
           <p:nvPr/>
         </p:nvSpPr>
         <p:spPr>
           <a:xfrm>
-            <a:off x="640080" y="2011680"/>
-            <a:ext cx="10881360" cy="713232"/>
-          </a:xfrm>
-          <a:prstGeom prst="rect">
-            <a:avLst/>
+            <a:off x="640080" y="1874519"/>
+            <a:ext cx="10881360" cy="731520"/>
+          </a:xfrm>
+          <a:prstGeom prst="roundRect">
+            <a:avLst>
+              <a:gd name="adj" fmla="val 6000"/>
+            </a:avLst>
           </a:prstGeom>
           <a:solidFill>
             <a:srgbClr val="FFFFFF"/>
@@ -11581,17 +11735,19 @@
       </p:sp>
       <p:sp>
         <p:nvSpPr>
-          <p:cNvPr id="9" name="Rectangle 8"/>
+          <p:cNvPr id="9" name="Rounded Rectangle 8"/>
           <p:cNvSpPr/>
           <p:nvPr/>
         </p:nvSpPr>
         <p:spPr>
           <a:xfrm>
-            <a:off x="914400" y="2313432"/>
+            <a:off x="914400" y="2185415"/>
             <a:ext cx="109728" cy="109728"/>
           </a:xfrm>
-          <a:prstGeom prst="rect">
-            <a:avLst/>
+          <a:prstGeom prst="roundRect">
+            <a:avLst>
+              <a:gd name="adj" fmla="val 35000"/>
+            </a:avLst>
           </a:prstGeom>
           <a:solidFill>
             <a:srgbClr val="2D4A3E"/>
@@ -11631,8 +11787,8 @@
         </p:nvSpPr>
         <p:spPr>
           <a:xfrm>
-            <a:off x="1188719" y="2011680"/>
-            <a:ext cx="2743200" cy="713232"/>
+            <a:off x="1188719" y="1874519"/>
+            <a:ext cx="2743200" cy="731520"/>
           </a:xfrm>
           <a:prstGeom prst="rect">
             <a:avLst/>
@@ -11647,7 +11803,7 @@
           <a:p>
             <a:pPr algn="l"/>
             <a:r>
-              <a:rPr sz="1150">
+              <a:rPr sz="1500">
                 <a:solidFill>
                   <a:srgbClr val="2C2418"/>
                 </a:solidFill>
@@ -11667,8 +11823,8 @@
         </p:nvSpPr>
         <p:spPr>
           <a:xfrm>
-            <a:off x="4114800" y="2011680"/>
-            <a:ext cx="7223760" cy="713232"/>
+            <a:off x="4114800" y="1874519"/>
+            <a:ext cx="7223760" cy="731520"/>
           </a:xfrm>
           <a:prstGeom prst="rect">
             <a:avLst/>
@@ -11687,7 +11843,7 @@
               </a:lnSpc>
             </a:pPr>
             <a:r>
-              <a:rPr sz="1050">
+              <a:rPr sz="1400">
                 <a:solidFill>
                   <a:srgbClr val="6B6356"/>
                 </a:solidFill>
@@ -11701,17 +11857,19 @@
       </p:sp>
       <p:sp>
         <p:nvSpPr>
-          <p:cNvPr id="12" name="Rectangle 11"/>
+          <p:cNvPr id="12" name="Rounded Rectangle 11"/>
           <p:cNvSpPr/>
           <p:nvPr/>
         </p:nvSpPr>
         <p:spPr>
           <a:xfrm>
-            <a:off x="676656" y="2871216"/>
-            <a:ext cx="10881360" cy="713232"/>
-          </a:xfrm>
-          <a:prstGeom prst="rect">
-            <a:avLst/>
+            <a:off x="676656" y="2752344"/>
+            <a:ext cx="10881360" cy="731520"/>
+          </a:xfrm>
+          <a:prstGeom prst="roundRect">
+            <a:avLst>
+              <a:gd name="adj" fmla="val 6000"/>
+            </a:avLst>
           </a:prstGeom>
           <a:solidFill>
             <a:srgbClr val="D5C9B4"/>
@@ -11745,17 +11903,19 @@
       </p:sp>
       <p:sp>
         <p:nvSpPr>
-          <p:cNvPr id="13" name="Rectangle 12"/>
+          <p:cNvPr id="13" name="Rounded Rectangle 12"/>
           <p:cNvSpPr/>
           <p:nvPr/>
         </p:nvSpPr>
         <p:spPr>
           <a:xfrm>
-            <a:off x="640080" y="2834640"/>
-            <a:ext cx="10881360" cy="713232"/>
-          </a:xfrm>
-          <a:prstGeom prst="rect">
-            <a:avLst/>
+            <a:off x="640080" y="2715768"/>
+            <a:ext cx="10881360" cy="731520"/>
+          </a:xfrm>
+          <a:prstGeom prst="roundRect">
+            <a:avLst>
+              <a:gd name="adj" fmla="val 6000"/>
+            </a:avLst>
           </a:prstGeom>
           <a:solidFill>
             <a:srgbClr val="FFFFFF"/>
@@ -11791,17 +11951,19 @@
       </p:sp>
       <p:sp>
         <p:nvSpPr>
-          <p:cNvPr id="14" name="Rectangle 13"/>
+          <p:cNvPr id="14" name="Rounded Rectangle 13"/>
           <p:cNvSpPr/>
           <p:nvPr/>
         </p:nvSpPr>
         <p:spPr>
           <a:xfrm>
-            <a:off x="914400" y="3136392"/>
+            <a:off x="914400" y="3026663"/>
             <a:ext cx="109728" cy="109728"/>
           </a:xfrm>
-          <a:prstGeom prst="rect">
-            <a:avLst/>
+          <a:prstGeom prst="roundRect">
+            <a:avLst>
+              <a:gd name="adj" fmla="val 35000"/>
+            </a:avLst>
           </a:prstGeom>
           <a:solidFill>
             <a:srgbClr val="2D4A3E"/>
@@ -11841,8 +12003,8 @@
         </p:nvSpPr>
         <p:spPr>
           <a:xfrm>
-            <a:off x="1188719" y="2834640"/>
-            <a:ext cx="2743200" cy="713232"/>
+            <a:off x="1188719" y="2715768"/>
+            <a:ext cx="2743200" cy="731520"/>
           </a:xfrm>
           <a:prstGeom prst="rect">
             <a:avLst/>
@@ -11857,7 +12019,7 @@
           <a:p>
             <a:pPr algn="l"/>
             <a:r>
-              <a:rPr sz="1150">
+              <a:rPr sz="1500">
                 <a:solidFill>
                   <a:srgbClr val="2C2418"/>
                 </a:solidFill>
@@ -11877,8 +12039,8 @@
         </p:nvSpPr>
         <p:spPr>
           <a:xfrm>
-            <a:off x="4114800" y="2834640"/>
-            <a:ext cx="7223760" cy="713232"/>
+            <a:off x="4114800" y="2715768"/>
+            <a:ext cx="7223760" cy="731520"/>
           </a:xfrm>
           <a:prstGeom prst="rect">
             <a:avLst/>
@@ -11897,7 +12059,7 @@
               </a:lnSpc>
             </a:pPr>
             <a:r>
-              <a:rPr sz="1050">
+              <a:rPr sz="1400">
                 <a:solidFill>
                   <a:srgbClr val="6B6356"/>
                 </a:solidFill>
@@ -11911,17 +12073,19 @@
       </p:sp>
       <p:sp>
         <p:nvSpPr>
-          <p:cNvPr id="17" name="Rectangle 16"/>
+          <p:cNvPr id="17" name="Rounded Rectangle 16"/>
           <p:cNvSpPr/>
           <p:nvPr/>
         </p:nvSpPr>
         <p:spPr>
           <a:xfrm>
-            <a:off x="676656" y="3694176"/>
-            <a:ext cx="10881360" cy="713232"/>
-          </a:xfrm>
-          <a:prstGeom prst="rect">
-            <a:avLst/>
+            <a:off x="676656" y="3593591"/>
+            <a:ext cx="10881360" cy="731520"/>
+          </a:xfrm>
+          <a:prstGeom prst="roundRect">
+            <a:avLst>
+              <a:gd name="adj" fmla="val 6000"/>
+            </a:avLst>
           </a:prstGeom>
           <a:solidFill>
             <a:srgbClr val="D5C9B4"/>
@@ -11955,17 +12119,19 @@
       </p:sp>
       <p:sp>
         <p:nvSpPr>
-          <p:cNvPr id="18" name="Rectangle 17"/>
+          <p:cNvPr id="18" name="Rounded Rectangle 17"/>
           <p:cNvSpPr/>
           <p:nvPr/>
         </p:nvSpPr>
         <p:spPr>
           <a:xfrm>
-            <a:off x="640080" y="3657600"/>
-            <a:ext cx="10881360" cy="713232"/>
-          </a:xfrm>
-          <a:prstGeom prst="rect">
-            <a:avLst/>
+            <a:off x="640080" y="3557015"/>
+            <a:ext cx="10881360" cy="731520"/>
+          </a:xfrm>
+          <a:prstGeom prst="roundRect">
+            <a:avLst>
+              <a:gd name="adj" fmla="val 6000"/>
+            </a:avLst>
           </a:prstGeom>
           <a:solidFill>
             <a:srgbClr val="FFFFFF"/>
@@ -12001,17 +12167,19 @@
       </p:sp>
       <p:sp>
         <p:nvSpPr>
-          <p:cNvPr id="19" name="Rectangle 18"/>
+          <p:cNvPr id="19" name="Rounded Rectangle 18"/>
           <p:cNvSpPr/>
           <p:nvPr/>
         </p:nvSpPr>
         <p:spPr>
           <a:xfrm>
-            <a:off x="914400" y="3959352"/>
+            <a:off x="914400" y="3867912"/>
             <a:ext cx="109728" cy="109728"/>
           </a:xfrm>
-          <a:prstGeom prst="rect">
-            <a:avLst/>
+          <a:prstGeom prst="roundRect">
+            <a:avLst>
+              <a:gd name="adj" fmla="val 35000"/>
+            </a:avLst>
           </a:prstGeom>
           <a:solidFill>
             <a:srgbClr val="2D4A3E"/>
@@ -12051,8 +12219,8 @@
         </p:nvSpPr>
         <p:spPr>
           <a:xfrm>
-            <a:off x="1188719" y="3657600"/>
-            <a:ext cx="2743200" cy="713232"/>
+            <a:off x="1188719" y="3557015"/>
+            <a:ext cx="2743200" cy="731520"/>
           </a:xfrm>
           <a:prstGeom prst="rect">
             <a:avLst/>
@@ -12067,7 +12235,7 @@
           <a:p>
             <a:pPr algn="l"/>
             <a:r>
-              <a:rPr sz="1150">
+              <a:rPr sz="1500">
                 <a:solidFill>
                   <a:srgbClr val="2C2418"/>
                 </a:solidFill>
@@ -12087,8 +12255,8 @@
         </p:nvSpPr>
         <p:spPr>
           <a:xfrm>
-            <a:off x="4114800" y="3657600"/>
-            <a:ext cx="7223760" cy="713232"/>
+            <a:off x="4114800" y="3557015"/>
+            <a:ext cx="7223760" cy="731520"/>
           </a:xfrm>
           <a:prstGeom prst="rect">
             <a:avLst/>
@@ -12107,7 +12275,7 @@
               </a:lnSpc>
             </a:pPr>
             <a:r>
-              <a:rPr sz="1050">
+              <a:rPr sz="1400">
                 <a:solidFill>
                   <a:srgbClr val="6B6356"/>
                 </a:solidFill>
@@ -12121,17 +12289,19 @@
       </p:sp>
       <p:sp>
         <p:nvSpPr>
-          <p:cNvPr id="22" name="Rectangle 21"/>
+          <p:cNvPr id="22" name="Rounded Rectangle 21"/>
           <p:cNvSpPr/>
           <p:nvPr/>
         </p:nvSpPr>
         <p:spPr>
           <a:xfrm>
-            <a:off x="676656" y="4517136"/>
-            <a:ext cx="10881360" cy="713232"/>
-          </a:xfrm>
-          <a:prstGeom prst="rect">
-            <a:avLst/>
+            <a:off x="676656" y="4434840"/>
+            <a:ext cx="10881360" cy="731520"/>
+          </a:xfrm>
+          <a:prstGeom prst="roundRect">
+            <a:avLst>
+              <a:gd name="adj" fmla="val 6000"/>
+            </a:avLst>
           </a:prstGeom>
           <a:solidFill>
             <a:srgbClr val="D5C9B4"/>
@@ -12165,17 +12335,19 @@
       </p:sp>
       <p:sp>
         <p:nvSpPr>
-          <p:cNvPr id="23" name="Rectangle 22"/>
+          <p:cNvPr id="23" name="Rounded Rectangle 22"/>
           <p:cNvSpPr/>
           <p:nvPr/>
         </p:nvSpPr>
         <p:spPr>
           <a:xfrm>
-            <a:off x="640080" y="4480560"/>
-            <a:ext cx="10881360" cy="713232"/>
-          </a:xfrm>
-          <a:prstGeom prst="rect">
-            <a:avLst/>
+            <a:off x="640080" y="4398264"/>
+            <a:ext cx="10881360" cy="731520"/>
+          </a:xfrm>
+          <a:prstGeom prst="roundRect">
+            <a:avLst>
+              <a:gd name="adj" fmla="val 6000"/>
+            </a:avLst>
           </a:prstGeom>
           <a:solidFill>
             <a:srgbClr val="FFFFFF"/>
@@ -12211,17 +12383,19 @@
       </p:sp>
       <p:sp>
         <p:nvSpPr>
-          <p:cNvPr id="24" name="Rectangle 23"/>
+          <p:cNvPr id="24" name="Rounded Rectangle 23"/>
           <p:cNvSpPr/>
           <p:nvPr/>
         </p:nvSpPr>
         <p:spPr>
           <a:xfrm>
-            <a:off x="914400" y="4782312"/>
+            <a:off x="914400" y="4709160"/>
             <a:ext cx="109728" cy="109728"/>
           </a:xfrm>
-          <a:prstGeom prst="rect">
-            <a:avLst/>
+          <a:prstGeom prst="roundRect">
+            <a:avLst>
+              <a:gd name="adj" fmla="val 35000"/>
+            </a:avLst>
           </a:prstGeom>
           <a:solidFill>
             <a:srgbClr val="2D4A3E"/>
@@ -12261,8 +12435,8 @@
         </p:nvSpPr>
         <p:spPr>
           <a:xfrm>
-            <a:off x="1188719" y="4480560"/>
-            <a:ext cx="2743200" cy="713232"/>
+            <a:off x="1188719" y="4398264"/>
+            <a:ext cx="2743200" cy="731520"/>
           </a:xfrm>
           <a:prstGeom prst="rect">
             <a:avLst/>
@@ -12277,7 +12451,7 @@
           <a:p>
             <a:pPr algn="l"/>
             <a:r>
-              <a:rPr sz="1150">
+              <a:rPr sz="1500">
                 <a:solidFill>
                   <a:srgbClr val="2C2418"/>
                 </a:solidFill>
@@ -12297,8 +12471,8 @@
         </p:nvSpPr>
         <p:spPr>
           <a:xfrm>
-            <a:off x="4114800" y="4480560"/>
-            <a:ext cx="7223760" cy="713232"/>
+            <a:off x="4114800" y="4398264"/>
+            <a:ext cx="7223760" cy="731520"/>
           </a:xfrm>
           <a:prstGeom prst="rect">
             <a:avLst/>
@@ -12317,7 +12491,7 @@
               </a:lnSpc>
             </a:pPr>
             <a:r>
-              <a:rPr sz="1050">
+              <a:rPr sz="1400">
                 <a:solidFill>
                   <a:srgbClr val="6B6356"/>
                 </a:solidFill>
@@ -12337,7 +12511,7 @@
         </p:nvSpPr>
         <p:spPr>
           <a:xfrm>
-            <a:off x="640080" y="5440680"/>
+            <a:off x="640080" y="5349240"/>
             <a:ext cx="4572000" cy="274320"/>
           </a:xfrm>
           <a:prstGeom prst="rect">
@@ -12353,7 +12527,7 @@
           <a:p>
             <a:pPr algn="l"/>
             <a:r>
-              <a:rPr sz="1000">
+              <a:rPr sz="1300">
                 <a:solidFill>
                   <a:srgbClr val="2D4A3E"/>
                 </a:solidFill>
@@ -12373,8 +12547,8 @@
         </p:nvSpPr>
         <p:spPr>
           <a:xfrm>
-            <a:off x="640080" y="5760720"/>
-            <a:ext cx="10881360" cy="914400"/>
+            <a:off x="640080" y="5715000"/>
+            <a:ext cx="10881360" cy="1005840"/>
           </a:xfrm>
           <a:prstGeom prst="rect">
             <a:avLst/>
@@ -12389,11 +12563,11 @@
           <a:p>
             <a:pPr algn="l">
               <a:lnSpc>
-                <a:spcPct val="145000"/>
+                <a:spcPct val="150000"/>
               </a:lnSpc>
             </a:pPr>
             <a:r>
-              <a:rPr sz="1000">
+              <a:rPr sz="1300">
                 <a:solidFill>
                   <a:srgbClr val="6B6356"/>
                 </a:solidFill>
@@ -12406,11 +12580,11 @@
           <a:p>
             <a:pPr algn="l">
               <a:lnSpc>
-                <a:spcPct val="145000"/>
+                <a:spcPct val="150000"/>
               </a:lnSpc>
             </a:pPr>
             <a:r>
-              <a:rPr sz="1000">
+              <a:rPr sz="1300">
                 <a:solidFill>
                   <a:srgbClr val="6B6356"/>
                 </a:solidFill>
@@ -12423,11 +12597,11 @@
           <a:p>
             <a:pPr algn="l">
               <a:lnSpc>
-                <a:spcPct val="145000"/>
+                <a:spcPct val="150000"/>
               </a:lnSpc>
             </a:pPr>
             <a:r>
-              <a:rPr sz="1000">
+              <a:rPr sz="1300">
                 <a:solidFill>
                   <a:srgbClr val="6B6356"/>
                 </a:solidFill>
@@ -12581,7 +12755,7 @@
         </p:nvSpPr>
         <p:spPr>
           <a:xfrm>
-            <a:off x="640080" y="1600200"/>
+            <a:off x="640080" y="1481328"/>
             <a:ext cx="10881360" cy="13716"/>
           </a:xfrm>
           <a:prstGeom prst="rect">
@@ -12641,7 +12815,7 @@
           <a:p>
             <a:pPr algn="r"/>
             <a:r>
-              <a:rPr sz="900">
+              <a:rPr sz="1150">
                 <a:solidFill>
                   <a:srgbClr val="9B9182"/>
                 </a:solidFill>
@@ -12655,17 +12829,19 @@
       </p:sp>
       <p:sp>
         <p:nvSpPr>
-          <p:cNvPr id="7" name="Rectangle 6"/>
+          <p:cNvPr id="7" name="Rounded Rectangle 6"/>
           <p:cNvSpPr/>
           <p:nvPr/>
         </p:nvSpPr>
         <p:spPr>
           <a:xfrm>
-            <a:off x="676656" y="1956816"/>
-            <a:ext cx="5577840" cy="3840480"/>
-          </a:xfrm>
-          <a:prstGeom prst="rect">
-            <a:avLst/>
+            <a:off x="676656" y="1865376"/>
+            <a:ext cx="5577840" cy="3108960"/>
+          </a:xfrm>
+          <a:prstGeom prst="roundRect">
+            <a:avLst>
+              <a:gd name="adj" fmla="val 6000"/>
+            </a:avLst>
           </a:prstGeom>
           <a:solidFill>
             <a:srgbClr val="D5C9B4"/>
@@ -12699,17 +12875,19 @@
       </p:sp>
       <p:sp>
         <p:nvSpPr>
-          <p:cNvPr id="8" name="Rectangle 7"/>
+          <p:cNvPr id="8" name="Rounded Rectangle 7"/>
           <p:cNvSpPr/>
           <p:nvPr/>
         </p:nvSpPr>
         <p:spPr>
           <a:xfrm>
-            <a:off x="640080" y="1920240"/>
-            <a:ext cx="5577840" cy="3840480"/>
-          </a:xfrm>
-          <a:prstGeom prst="rect">
-            <a:avLst/>
+            <a:off x="640080" y="1828800"/>
+            <a:ext cx="5577840" cy="3108960"/>
+          </a:xfrm>
+          <a:prstGeom prst="roundRect">
+            <a:avLst>
+              <a:gd name="adj" fmla="val 6000"/>
+            </a:avLst>
           </a:prstGeom>
           <a:solidFill>
             <a:srgbClr val="FFFFFF"/>
@@ -12751,7 +12929,7 @@
         </p:nvSpPr>
         <p:spPr>
           <a:xfrm>
-            <a:off x="868680" y="2103120"/>
+            <a:off x="868680" y="2011680"/>
             <a:ext cx="3657600" cy="274320"/>
           </a:xfrm>
           <a:prstGeom prst="rect">
@@ -12767,7 +12945,7 @@
           <a:p>
             <a:pPr algn="l"/>
             <a:r>
-              <a:rPr sz="1000">
+              <a:rPr sz="1300">
                 <a:solidFill>
                   <a:srgbClr val="8B2635"/>
                 </a:solidFill>
@@ -12787,8 +12965,8 @@
         </p:nvSpPr>
         <p:spPr>
           <a:xfrm>
-            <a:off x="868680" y="2423160"/>
-            <a:ext cx="5303520" cy="457200"/>
+            <a:off x="868680" y="2331720"/>
+            <a:ext cx="5303520" cy="411480"/>
           </a:xfrm>
           <a:prstGeom prst="rect">
             <a:avLst/>
@@ -12803,7 +12981,7 @@
           <a:p>
             <a:pPr algn="l"/>
             <a:r>
-              <a:rPr sz="1400">
+              <a:rPr sz="1750">
                 <a:solidFill>
                   <a:srgbClr val="2C2418"/>
                 </a:solidFill>
@@ -12823,8 +13001,8 @@
         </p:nvSpPr>
         <p:spPr>
           <a:xfrm>
-            <a:off x="868680" y="2926080"/>
-            <a:ext cx="5303520" cy="777240"/>
+            <a:off x="868680" y="2788920"/>
+            <a:ext cx="5303520" cy="731520"/>
           </a:xfrm>
           <a:prstGeom prst="rect">
             <a:avLst/>
@@ -12843,7 +13021,7 @@
               </a:lnSpc>
             </a:pPr>
             <a:r>
-              <a:rPr sz="1100">
+              <a:rPr sz="1400">
                 <a:solidFill>
                   <a:srgbClr val="6B6356"/>
                 </a:solidFill>
@@ -12860,7 +13038,7 @@
               </a:lnSpc>
             </a:pPr>
             <a:r>
-              <a:rPr sz="1100">
+              <a:rPr sz="1400">
                 <a:solidFill>
                   <a:srgbClr val="6B6356"/>
                 </a:solidFill>
@@ -12880,7 +13058,7 @@
         </p:nvSpPr>
         <p:spPr>
           <a:xfrm>
-            <a:off x="868680" y="3886200"/>
+            <a:off x="868680" y="3611880"/>
             <a:ext cx="3657600" cy="274320"/>
           </a:xfrm>
           <a:prstGeom prst="rect">
@@ -12896,7 +13074,7 @@
           <a:p>
             <a:pPr algn="l"/>
             <a:r>
-              <a:rPr sz="1000">
+              <a:rPr sz="1300">
                 <a:solidFill>
                   <a:srgbClr val="2D4A3E"/>
                 </a:solidFill>
@@ -12916,8 +13094,8 @@
         </p:nvSpPr>
         <p:spPr>
           <a:xfrm>
-            <a:off x="868680" y="4206240"/>
-            <a:ext cx="5303520" cy="1417320"/>
+            <a:off x="868680" y="3931920"/>
+            <a:ext cx="5303520" cy="960120"/>
           </a:xfrm>
           <a:prstGeom prst="rect">
             <a:avLst/>
@@ -12932,11 +13110,11 @@
           <a:p>
             <a:pPr algn="l">
               <a:lnSpc>
-                <a:spcPct val="155000"/>
+                <a:spcPct val="145000"/>
               </a:lnSpc>
             </a:pPr>
             <a:r>
-              <a:rPr sz="1150">
+              <a:rPr sz="1450">
                 <a:solidFill>
                   <a:srgbClr val="2C2418"/>
                 </a:solidFill>
@@ -12949,11 +13127,11 @@
           <a:p>
             <a:pPr algn="l">
               <a:lnSpc>
-                <a:spcPct val="155000"/>
+                <a:spcPct val="145000"/>
               </a:lnSpc>
             </a:pPr>
             <a:r>
-              <a:rPr sz="1150">
+              <a:rPr sz="1450">
                 <a:solidFill>
                   <a:srgbClr val="2C2418"/>
                 </a:solidFill>
@@ -12966,11 +13144,11 @@
           <a:p>
             <a:pPr algn="l">
               <a:lnSpc>
-                <a:spcPct val="155000"/>
+                <a:spcPct val="145000"/>
               </a:lnSpc>
             </a:pPr>
             <a:r>
-              <a:rPr sz="1150">
+              <a:rPr sz="1450">
                 <a:solidFill>
                   <a:srgbClr val="2C2418"/>
                 </a:solidFill>
@@ -12984,17 +13162,19 @@
       </p:sp>
       <p:sp>
         <p:nvSpPr>
-          <p:cNvPr id="14" name="Rectangle 13"/>
+          <p:cNvPr id="14" name="Rounded Rectangle 13"/>
           <p:cNvSpPr/>
           <p:nvPr/>
         </p:nvSpPr>
         <p:spPr>
           <a:xfrm>
-            <a:off x="6437376" y="1956816"/>
-            <a:ext cx="5212080" cy="3840480"/>
-          </a:xfrm>
-          <a:prstGeom prst="rect">
-            <a:avLst/>
+            <a:off x="6437376" y="1865376"/>
+            <a:ext cx="5212080" cy="3108960"/>
+          </a:xfrm>
+          <a:prstGeom prst="roundRect">
+            <a:avLst>
+              <a:gd name="adj" fmla="val 6000"/>
+            </a:avLst>
           </a:prstGeom>
           <a:solidFill>
             <a:srgbClr val="D5C9B4"/>
@@ -13028,17 +13208,19 @@
       </p:sp>
       <p:sp>
         <p:nvSpPr>
-          <p:cNvPr id="15" name="Rectangle 14"/>
+          <p:cNvPr id="15" name="Rounded Rectangle 14"/>
           <p:cNvSpPr/>
           <p:nvPr/>
         </p:nvSpPr>
         <p:spPr>
           <a:xfrm>
-            <a:off x="6400800" y="1920240"/>
-            <a:ext cx="5212080" cy="3840480"/>
-          </a:xfrm>
-          <a:prstGeom prst="rect">
-            <a:avLst/>
+            <a:off x="6400800" y="1828800"/>
+            <a:ext cx="5212080" cy="3108960"/>
+          </a:xfrm>
+          <a:prstGeom prst="roundRect">
+            <a:avLst>
+              <a:gd name="adj" fmla="val 6000"/>
+            </a:avLst>
           </a:prstGeom>
           <a:solidFill>
             <a:srgbClr val="FFFFFF"/>
@@ -13080,7 +13262,7 @@
         </p:nvSpPr>
         <p:spPr>
           <a:xfrm>
-            <a:off x="6629400" y="2103120"/>
+            <a:off x="6629400" y="2011680"/>
             <a:ext cx="3657600" cy="274320"/>
           </a:xfrm>
           <a:prstGeom prst="rect">
@@ -13096,7 +13278,7 @@
           <a:p>
             <a:pPr algn="l"/>
             <a:r>
-              <a:rPr sz="1000">
+              <a:rPr sz="1300">
                 <a:solidFill>
                   <a:srgbClr val="2D4A3E"/>
                 </a:solidFill>
@@ -13110,17 +13292,19 @@
       </p:sp>
       <p:sp>
         <p:nvSpPr>
-          <p:cNvPr id="17" name="Rectangle 16"/>
+          <p:cNvPr id="17" name="Rounded Rectangle 16"/>
           <p:cNvSpPr/>
           <p:nvPr/>
         </p:nvSpPr>
         <p:spPr>
           <a:xfrm>
-            <a:off x="6629400" y="2514600"/>
+            <a:off x="6629400" y="2423160"/>
             <a:ext cx="4754880" cy="365760"/>
           </a:xfrm>
-          <a:prstGeom prst="rect">
-            <a:avLst/>
+          <a:prstGeom prst="roundRect">
+            <a:avLst>
+              <a:gd name="adj" fmla="val 6000"/>
+            </a:avLst>
           </a:prstGeom>
           <a:solidFill>
             <a:srgbClr val="F9F5EE"/>
@@ -13160,7 +13344,7 @@
         </p:nvSpPr>
         <p:spPr>
           <a:xfrm>
-            <a:off x="6766560" y="2514600"/>
+            <a:off x="6766560" y="2423160"/>
             <a:ext cx="1737360" cy="365760"/>
           </a:xfrm>
           <a:prstGeom prst="rect">
@@ -13176,7 +13360,7 @@
           <a:p>
             <a:pPr algn="l"/>
             <a:r>
-              <a:rPr sz="1050">
+              <a:rPr sz="1350">
                 <a:solidFill>
                   <a:srgbClr val="2C2418"/>
                 </a:solidFill>
@@ -13196,7 +13380,7 @@
         </p:nvSpPr>
         <p:spPr>
           <a:xfrm>
-            <a:off x="8503920" y="2514600"/>
+            <a:off x="8503920" y="2423160"/>
             <a:ext cx="1371600" cy="365760"/>
           </a:xfrm>
           <a:prstGeom prst="rect">
@@ -13212,7 +13396,7 @@
           <a:p>
             <a:pPr algn="ctr"/>
             <a:r>
-              <a:rPr sz="1050">
+              <a:rPr sz="1350">
                 <a:solidFill>
                   <a:srgbClr val="6B6356"/>
                 </a:solidFill>
@@ -13232,7 +13416,7 @@
         </p:nvSpPr>
         <p:spPr>
           <a:xfrm>
-            <a:off x="9875520" y="2514600"/>
+            <a:off x="9875520" y="2423160"/>
             <a:ext cx="1463040" cy="365760"/>
           </a:xfrm>
           <a:prstGeom prst="rect">
@@ -13248,7 +13432,7 @@
           <a:p>
             <a:pPr algn="ctr"/>
             <a:r>
-              <a:rPr sz="1050">
+              <a:rPr sz="1350">
                 <a:solidFill>
                   <a:srgbClr val="2D4A3E"/>
                 </a:solidFill>
@@ -13268,8 +13452,8 @@
         </p:nvSpPr>
         <p:spPr>
           <a:xfrm>
-            <a:off x="6766560" y="2926080"/>
-            <a:ext cx="1737360" cy="411480"/>
+            <a:off x="6766560" y="2834640"/>
+            <a:ext cx="1737360" cy="365760"/>
           </a:xfrm>
           <a:prstGeom prst="rect">
             <a:avLst/>
@@ -13284,7 +13468,7 @@
           <a:p>
             <a:pPr algn="l"/>
             <a:r>
-              <a:rPr sz="1100">
+              <a:rPr sz="1400">
                 <a:solidFill>
                   <a:srgbClr val="2C2418"/>
                 </a:solidFill>
@@ -13304,8 +13488,8 @@
         </p:nvSpPr>
         <p:spPr>
           <a:xfrm>
-            <a:off x="8503920" y="2926080"/>
-            <a:ext cx="1371600" cy="411480"/>
+            <a:off x="8503920" y="2834640"/>
+            <a:ext cx="1371600" cy="365760"/>
           </a:xfrm>
           <a:prstGeom prst="rect">
             <a:avLst/>
@@ -13320,7 +13504,7 @@
           <a:p>
             <a:pPr algn="ctr"/>
             <a:r>
-              <a:rPr sz="1100">
+              <a:rPr sz="1400">
                 <a:solidFill>
                   <a:srgbClr val="6B6356"/>
                 </a:solidFill>
@@ -13340,8 +13524,8 @@
         </p:nvSpPr>
         <p:spPr>
           <a:xfrm>
-            <a:off x="9875520" y="2926080"/>
-            <a:ext cx="1463040" cy="411480"/>
+            <a:off x="9875520" y="2834640"/>
+            <a:ext cx="1463040" cy="365760"/>
           </a:xfrm>
           <a:prstGeom prst="rect">
             <a:avLst/>
@@ -13356,7 +13540,7 @@
           <a:p>
             <a:pPr algn="ctr"/>
             <a:r>
-              <a:rPr sz="1100">
+              <a:rPr sz="1400">
                 <a:solidFill>
                   <a:srgbClr val="2D4A3E"/>
                 </a:solidFill>
@@ -13376,8 +13560,8 @@
         </p:nvSpPr>
         <p:spPr>
           <a:xfrm>
-            <a:off x="6766560" y="3383280"/>
-            <a:ext cx="1737360" cy="411480"/>
+            <a:off x="6766560" y="3218688"/>
+            <a:ext cx="1737360" cy="365760"/>
           </a:xfrm>
           <a:prstGeom prst="rect">
             <a:avLst/>
@@ -13392,7 +13576,7 @@
           <a:p>
             <a:pPr algn="l"/>
             <a:r>
-              <a:rPr sz="1100">
+              <a:rPr sz="1400">
                 <a:solidFill>
                   <a:srgbClr val="2C2418"/>
                 </a:solidFill>
@@ -13412,8 +13596,8 @@
         </p:nvSpPr>
         <p:spPr>
           <a:xfrm>
-            <a:off x="8503920" y="3383280"/>
-            <a:ext cx="1371600" cy="411480"/>
+            <a:off x="8503920" y="3218688"/>
+            <a:ext cx="1371600" cy="365760"/>
           </a:xfrm>
           <a:prstGeom prst="rect">
             <a:avLst/>
@@ -13428,7 +13612,7 @@
           <a:p>
             <a:pPr algn="ctr"/>
             <a:r>
-              <a:rPr sz="1100">
+              <a:rPr sz="1400">
                 <a:solidFill>
                   <a:srgbClr val="6B6356"/>
                 </a:solidFill>
@@ -13448,8 +13632,8 @@
         </p:nvSpPr>
         <p:spPr>
           <a:xfrm>
-            <a:off x="9875520" y="3383280"/>
-            <a:ext cx="1463040" cy="411480"/>
+            <a:off x="9875520" y="3218688"/>
+            <a:ext cx="1463040" cy="365760"/>
           </a:xfrm>
           <a:prstGeom prst="rect">
             <a:avLst/>
@@ -13464,7 +13648,7 @@
           <a:p>
             <a:pPr algn="ctr"/>
             <a:r>
-              <a:rPr sz="1100">
+              <a:rPr sz="1400">
                 <a:solidFill>
                   <a:srgbClr val="2D4A3E"/>
                 </a:solidFill>
@@ -13484,8 +13668,8 @@
         </p:nvSpPr>
         <p:spPr>
           <a:xfrm>
-            <a:off x="6766560" y="3840480"/>
-            <a:ext cx="1737360" cy="411480"/>
+            <a:off x="6766560" y="3602736"/>
+            <a:ext cx="1737360" cy="365760"/>
           </a:xfrm>
           <a:prstGeom prst="rect">
             <a:avLst/>
@@ -13500,7 +13684,7 @@
           <a:p>
             <a:pPr algn="l"/>
             <a:r>
-              <a:rPr sz="1100">
+              <a:rPr sz="1400">
                 <a:solidFill>
                   <a:srgbClr val="2C2418"/>
                 </a:solidFill>
@@ -13520,8 +13704,8 @@
         </p:nvSpPr>
         <p:spPr>
           <a:xfrm>
-            <a:off x="8503920" y="3840480"/>
-            <a:ext cx="1371600" cy="411480"/>
+            <a:off x="8503920" y="3602736"/>
+            <a:ext cx="1371600" cy="365760"/>
           </a:xfrm>
           <a:prstGeom prst="rect">
             <a:avLst/>
@@ -13536,7 +13720,7 @@
           <a:p>
             <a:pPr algn="ctr"/>
             <a:r>
-              <a:rPr sz="1100">
+              <a:rPr sz="1400">
                 <a:solidFill>
                   <a:srgbClr val="6B6356"/>
                 </a:solidFill>
@@ -13556,8 +13740,8 @@
         </p:nvSpPr>
         <p:spPr>
           <a:xfrm>
-            <a:off x="9875520" y="3840480"/>
-            <a:ext cx="1463040" cy="411480"/>
+            <a:off x="9875520" y="3602736"/>
+            <a:ext cx="1463040" cy="365760"/>
           </a:xfrm>
           <a:prstGeom prst="rect">
             <a:avLst/>
@@ -13572,7 +13756,7 @@
           <a:p>
             <a:pPr algn="ctr"/>
             <a:r>
-              <a:rPr sz="1100">
+              <a:rPr sz="1400">
                 <a:solidFill>
                   <a:srgbClr val="2D4A3E"/>
                 </a:solidFill>
@@ -13592,8 +13776,8 @@
         </p:nvSpPr>
         <p:spPr>
           <a:xfrm>
-            <a:off x="6766560" y="4297680"/>
-            <a:ext cx="1737360" cy="411480"/>
+            <a:off x="6766560" y="3986784"/>
+            <a:ext cx="1737360" cy="365760"/>
           </a:xfrm>
           <a:prstGeom prst="rect">
             <a:avLst/>
@@ -13608,7 +13792,7 @@
           <a:p>
             <a:pPr algn="l"/>
             <a:r>
-              <a:rPr sz="1100">
+              <a:rPr sz="1400">
                 <a:solidFill>
                   <a:srgbClr val="2C2418"/>
                 </a:solidFill>
@@ -13628,8 +13812,8 @@
         </p:nvSpPr>
         <p:spPr>
           <a:xfrm>
-            <a:off x="8503920" y="4297680"/>
-            <a:ext cx="1371600" cy="411480"/>
+            <a:off x="8503920" y="3986784"/>
+            <a:ext cx="1371600" cy="365760"/>
           </a:xfrm>
           <a:prstGeom prst="rect">
             <a:avLst/>
@@ -13644,7 +13828,7 @@
           <a:p>
             <a:pPr algn="ctr"/>
             <a:r>
-              <a:rPr sz="1100">
+              <a:rPr sz="1400">
                 <a:solidFill>
                   <a:srgbClr val="6B6356"/>
                 </a:solidFill>
@@ -13664,8 +13848,8 @@
         </p:nvSpPr>
         <p:spPr>
           <a:xfrm>
-            <a:off x="9875520" y="4297680"/>
-            <a:ext cx="1463040" cy="411480"/>
+            <a:off x="9875520" y="3986784"/>
+            <a:ext cx="1463040" cy="365760"/>
           </a:xfrm>
           <a:prstGeom prst="rect">
             <a:avLst/>
@@ -13680,7 +13864,7 @@
           <a:p>
             <a:pPr algn="ctr"/>
             <a:r>
-              <a:rPr sz="1100">
+              <a:rPr sz="1400">
                 <a:solidFill>
                   <a:srgbClr val="2D4A3E"/>
                 </a:solidFill>
@@ -13694,14 +13878,108 @@
       </p:sp>
       <p:sp>
         <p:nvSpPr>
-          <p:cNvPr id="33" name="TextBox 32"/>
+          <p:cNvPr id="33" name="Rounded Rectangle 32"/>
+          <p:cNvSpPr/>
+          <p:nvPr/>
+        </p:nvSpPr>
+        <p:spPr>
+          <a:xfrm>
+            <a:off x="676656" y="5157216"/>
+            <a:ext cx="10972800" cy="1508760"/>
+          </a:xfrm>
+          <a:prstGeom prst="roundRect">
+            <a:avLst>
+              <a:gd name="adj" fmla="val 6000"/>
+            </a:avLst>
+          </a:prstGeom>
+          <a:solidFill>
+            <a:srgbClr val="D5C9B4"/>
+          </a:solidFill>
+          <a:ln>
+            <a:noFill/>
+          </a:ln>
+          <a:effectLst/>
+        </p:spPr>
+        <p:style>
+          <a:lnRef idx="1">
+            <a:schemeClr val="accent1"/>
+          </a:lnRef>
+          <a:fillRef idx="3">
+            <a:schemeClr val="accent1"/>
+          </a:fillRef>
+          <a:effectRef idx="2">
+            <a:schemeClr val="accent1"/>
+          </a:effectRef>
+          <a:fontRef idx="minor">
+            <a:schemeClr val="lt1"/>
+          </a:fontRef>
+        </p:style>
+        <p:txBody>
+          <a:bodyPr rtlCol="0" anchor="ctr"/>
+          <a:lstStyle/>
+          <a:p>
+            <a:pPr algn="ctr"/>
+          </a:p>
+        </p:txBody>
+      </p:sp>
+      <p:sp>
+        <p:nvSpPr>
+          <p:cNvPr id="34" name="Rounded Rectangle 33"/>
+          <p:cNvSpPr/>
+          <p:nvPr/>
+        </p:nvSpPr>
+        <p:spPr>
+          <a:xfrm>
+            <a:off x="640080" y="5120640"/>
+            <a:ext cx="10972800" cy="1508760"/>
+          </a:xfrm>
+          <a:prstGeom prst="roundRect">
+            <a:avLst>
+              <a:gd name="adj" fmla="val 6000"/>
+            </a:avLst>
+          </a:prstGeom>
+          <a:solidFill>
+            <a:srgbClr val="FFFFFF"/>
+          </a:solidFill>
+          <a:ln w="9525">
+            <a:solidFill>
+              <a:srgbClr val="E5DDD0"/>
+            </a:solidFill>
+          </a:ln>
+          <a:effectLst/>
+        </p:spPr>
+        <p:style>
+          <a:lnRef idx="1">
+            <a:schemeClr val="accent1"/>
+          </a:lnRef>
+          <a:fillRef idx="3">
+            <a:schemeClr val="accent1"/>
+          </a:fillRef>
+          <a:effectRef idx="2">
+            <a:schemeClr val="accent1"/>
+          </a:effectRef>
+          <a:fontRef idx="minor">
+            <a:schemeClr val="lt1"/>
+          </a:fontRef>
+        </p:style>
+        <p:txBody>
+          <a:bodyPr rtlCol="0" anchor="ctr"/>
+          <a:lstStyle/>
+          <a:p>
+            <a:pPr algn="ctr"/>
+          </a:p>
+        </p:txBody>
+      </p:sp>
+      <p:sp>
+        <p:nvSpPr>
+          <p:cNvPr id="35" name="TextBox 34"/>
           <p:cNvSpPr txBox="1"/>
           <p:nvPr/>
         </p:nvSpPr>
         <p:spPr>
           <a:xfrm>
-            <a:off x="640080" y="5897880"/>
-            <a:ext cx="3657600" cy="274320"/>
+            <a:off x="868680" y="5303520"/>
+            <a:ext cx="4572000" cy="274320"/>
           </a:xfrm>
           <a:prstGeom prst="rect">
             <a:avLst/>
@@ -13716,7 +13994,7 @@
           <a:p>
             <a:pPr algn="l"/>
             <a:r>
-              <a:rPr sz="1000">
+              <a:rPr sz="1300">
                 <a:solidFill>
                   <a:srgbClr val="8B2635"/>
                 </a:solidFill>
@@ -13730,14 +14008,14 @@
       </p:sp>
       <p:sp>
         <p:nvSpPr>
-          <p:cNvPr id="34" name="TextBox 33"/>
+          <p:cNvPr id="36" name="TextBox 35"/>
           <p:cNvSpPr txBox="1"/>
           <p:nvPr/>
         </p:nvSpPr>
         <p:spPr>
           <a:xfrm>
-            <a:off x="640080" y="6217920"/>
-            <a:ext cx="10972800" cy="502920"/>
+            <a:off x="868680" y="5669280"/>
+            <a:ext cx="10515600" cy="868680"/>
           </a:xfrm>
           <a:prstGeom prst="rect">
             <a:avLst/>
@@ -13752,18 +14030,52 @@
           <a:p>
             <a:pPr algn="l">
               <a:lnSpc>
-                <a:spcPct val="145000"/>
+                <a:spcPct val="140000"/>
               </a:lnSpc>
             </a:pPr>
             <a:r>
-              <a:rPr sz="950">
+              <a:rPr sz="1300">
                 <a:solidFill>
                   <a:srgbClr val="6B6356"/>
                 </a:solidFill>
                 <a:latin typeface="맑은 고딕"/>
                 <a:ea typeface="맑은 고딕"/>
               </a:rPr>
-              <a:t>•  Vercel Hobby 60초 / 일 1회 cron — backlog → Pro 또는 외부 워커 분리      •  자막 음역 (곽재식→곽제식) → description 해시태그를 LLM 정답 표기로 주입      •  배포 URL 공개 → Vercel Password Protection 또는 Supabase Auth</a:t>
+              <a:t>•  Vercel Hobby 60초 / 일 1회 cron — backlog 누적 → Pro 업그레이드 또는 외부 워커 분리</a:t>
+            </a:r>
+          </a:p>
+          <a:p>
+            <a:pPr algn="l">
+              <a:lnSpc>
+                <a:spcPct val="140000"/>
+              </a:lnSpc>
+            </a:pPr>
+            <a:r>
+              <a:rPr sz="1300">
+                <a:solidFill>
+                  <a:srgbClr val="6B6356"/>
+                </a:solidFill>
+                <a:latin typeface="맑은 고딕"/>
+                <a:ea typeface="맑은 고딕"/>
+              </a:rPr>
+              <a:t>•  자막 음역 (곽재식→곽제식) → description 해시태그를 LLM 정답 표기로 주입</a:t>
+            </a:r>
+          </a:p>
+          <a:p>
+            <a:pPr algn="l">
+              <a:lnSpc>
+                <a:spcPct val="140000"/>
+              </a:lnSpc>
+            </a:pPr>
+            <a:r>
+              <a:rPr sz="1300">
+                <a:solidFill>
+                  <a:srgbClr val="6B6356"/>
+                </a:solidFill>
+                <a:latin typeface="맑은 고딕"/>
+                <a:ea typeface="맑은 고딕"/>
+              </a:rPr>
+              <a:t>•  배포 URL 공개 → Vercel Password Protection 또는 Supabase Auth</a:t>
             </a:r>
           </a:p>
         </p:txBody>

</xml_diff>